<commit_message>
Fix PPT: correct image paths, fix text overlap, align to problem statement
</commit_message>
<xml_diff>
--- a/TRINETRA_AI_Presentation.pptx
+++ b/TRINETRA_AI_Presentation.pptx
@@ -3431,22 +3431,22 @@
         </p:nvSpPr>
         <p:spPr>
           <a:xfrm>
-            <a:off x="914400" y="1097280"/>
-            <a:ext cx="10058400" cy="731520"/>
-          </a:xfrm>
-          <a:prstGeom prst="rect">
-            <a:avLst/>
-          </a:prstGeom>
-          <a:noFill/>
-        </p:spPr>
-        <p:txBody>
-          <a:bodyPr wrap="square">
-            <a:spAutoFit/>
-          </a:bodyPr>
-          <a:lstStyle/>
-          <a:p>
-            <a:pPr algn="l">
-              <a:defRPr sz="3600" b="1">
+            <a:off x="914400" y="914400"/>
+            <a:ext cx="10058400" cy="594360"/>
+          </a:xfrm>
+          <a:prstGeom prst="rect">
+            <a:avLst/>
+          </a:prstGeom>
+          <a:noFill/>
+        </p:spPr>
+        <p:txBody>
+          <a:bodyPr wrap="square">
+            <a:spAutoFit/>
+          </a:bodyPr>
+          <a:lstStyle/>
+          <a:p>
+            <a:pPr algn="l">
+              <a:defRPr sz="3200" b="1">
                 <a:solidFill>
                   <a:srgbClr val="FFFFFF"/>
                 </a:solidFill>
@@ -3466,22 +3466,22 @@
         </p:nvSpPr>
         <p:spPr>
           <a:xfrm>
-            <a:off x="914400" y="1828800"/>
-            <a:ext cx="10058400" cy="457200"/>
-          </a:xfrm>
-          <a:prstGeom prst="rect">
-            <a:avLst/>
-          </a:prstGeom>
-          <a:noFill/>
-        </p:spPr>
-        <p:txBody>
-          <a:bodyPr wrap="square">
-            <a:spAutoFit/>
-          </a:bodyPr>
-          <a:lstStyle/>
-          <a:p>
-            <a:pPr algn="l">
-              <a:defRPr sz="1800" b="0">
+            <a:off x="914400" y="1600200"/>
+            <a:ext cx="10058400" cy="274320"/>
+          </a:xfrm>
+          <a:prstGeom prst="rect">
+            <a:avLst/>
+          </a:prstGeom>
+          <a:noFill/>
+        </p:spPr>
+        <p:txBody>
+          <a:bodyPr wrap="square">
+            <a:spAutoFit/>
+          </a:bodyPr>
+          <a:lstStyle/>
+          <a:p>
+            <a:pPr algn="l">
+              <a:defRPr sz="1400" b="0">
                 <a:solidFill>
                   <a:srgbClr val="9CA3AF"/>
                 </a:solidFill>
@@ -3501,7 +3501,7 @@
         </p:nvSpPr>
         <p:spPr>
           <a:xfrm>
-            <a:off x="365760" y="1920240"/>
+            <a:off x="365760" y="2194560"/>
             <a:ext cx="3566160" cy="2011680"/>
           </a:xfrm>
           <a:prstGeom prst="roundRect">
@@ -3546,7 +3546,7 @@
         </p:nvSpPr>
         <p:spPr>
           <a:xfrm>
-            <a:off x="457200" y="2011680"/>
+            <a:off x="457200" y="2286000"/>
             <a:ext cx="3383280" cy="365760"/>
           </a:xfrm>
           <a:prstGeom prst="roundRect">
@@ -3591,7 +3591,7 @@
         </p:nvSpPr>
         <p:spPr>
           <a:xfrm>
-            <a:off x="502920" y="2057400"/>
+            <a:off x="502920" y="2331720"/>
             <a:ext cx="3291840" cy="274320"/>
           </a:xfrm>
           <a:prstGeom prst="rect">
@@ -3626,7 +3626,7 @@
         </p:nvSpPr>
         <p:spPr>
           <a:xfrm>
-            <a:off x="502920" y="2423160"/>
+            <a:off x="502920" y="2697480"/>
             <a:ext cx="3291840" cy="1371600"/>
           </a:xfrm>
           <a:prstGeom prst="rect">
@@ -3669,7 +3669,7 @@
         </p:nvSpPr>
         <p:spPr>
           <a:xfrm>
-            <a:off x="4206240" y="1920240"/>
+            <a:off x="4206240" y="2194560"/>
             <a:ext cx="3566160" cy="2011680"/>
           </a:xfrm>
           <a:prstGeom prst="roundRect">
@@ -3714,7 +3714,7 @@
         </p:nvSpPr>
         <p:spPr>
           <a:xfrm>
-            <a:off x="4297680" y="2011680"/>
+            <a:off x="4297680" y="2286000"/>
             <a:ext cx="3383280" cy="365760"/>
           </a:xfrm>
           <a:prstGeom prst="roundRect">
@@ -3759,7 +3759,7 @@
         </p:nvSpPr>
         <p:spPr>
           <a:xfrm>
-            <a:off x="4343400" y="2057400"/>
+            <a:off x="4343400" y="2331720"/>
             <a:ext cx="3291840" cy="274320"/>
           </a:xfrm>
           <a:prstGeom prst="rect">
@@ -3794,7 +3794,7 @@
         </p:nvSpPr>
         <p:spPr>
           <a:xfrm>
-            <a:off x="4343400" y="2423160"/>
+            <a:off x="4343400" y="2697480"/>
             <a:ext cx="3291840" cy="1371600"/>
           </a:xfrm>
           <a:prstGeom prst="rect">
@@ -3837,7 +3837,7 @@
         </p:nvSpPr>
         <p:spPr>
           <a:xfrm>
-            <a:off x="8046720" y="1920240"/>
+            <a:off x="8046720" y="2194560"/>
             <a:ext cx="3566160" cy="2011680"/>
           </a:xfrm>
           <a:prstGeom prst="roundRect">
@@ -3882,7 +3882,7 @@
         </p:nvSpPr>
         <p:spPr>
           <a:xfrm>
-            <a:off x="8138160" y="2011680"/>
+            <a:off x="8138160" y="2286000"/>
             <a:ext cx="3383280" cy="365760"/>
           </a:xfrm>
           <a:prstGeom prst="roundRect">
@@ -3927,7 +3927,7 @@
         </p:nvSpPr>
         <p:spPr>
           <a:xfrm>
-            <a:off x="8183880" y="2057400"/>
+            <a:off x="8183880" y="2331720"/>
             <a:ext cx="3291840" cy="274320"/>
           </a:xfrm>
           <a:prstGeom prst="rect">
@@ -3962,7 +3962,7 @@
         </p:nvSpPr>
         <p:spPr>
           <a:xfrm>
-            <a:off x="8183880" y="2423160"/>
+            <a:off x="8183880" y="2697480"/>
             <a:ext cx="3291840" cy="1371600"/>
           </a:xfrm>
           <a:prstGeom prst="rect">
@@ -4005,7 +4005,7 @@
         </p:nvSpPr>
         <p:spPr>
           <a:xfrm>
-            <a:off x="365760" y="4206240"/>
+            <a:off x="365760" y="4480560"/>
             <a:ext cx="3566160" cy="2011680"/>
           </a:xfrm>
           <a:prstGeom prst="roundRect">
@@ -4050,7 +4050,7 @@
         </p:nvSpPr>
         <p:spPr>
           <a:xfrm>
-            <a:off x="457200" y="4297680"/>
+            <a:off x="457200" y="4572000"/>
             <a:ext cx="3383280" cy="365760"/>
           </a:xfrm>
           <a:prstGeom prst="roundRect">
@@ -4095,7 +4095,7 @@
         </p:nvSpPr>
         <p:spPr>
           <a:xfrm>
-            <a:off x="502920" y="4343400"/>
+            <a:off x="502920" y="4617720"/>
             <a:ext cx="3291840" cy="274320"/>
           </a:xfrm>
           <a:prstGeom prst="rect">
@@ -4130,7 +4130,7 @@
         </p:nvSpPr>
         <p:spPr>
           <a:xfrm>
-            <a:off x="502920" y="4709160"/>
+            <a:off x="502920" y="4983480"/>
             <a:ext cx="3291840" cy="1371600"/>
           </a:xfrm>
           <a:prstGeom prst="rect">
@@ -4173,7 +4173,7 @@
         </p:nvSpPr>
         <p:spPr>
           <a:xfrm>
-            <a:off x="4206240" y="4206240"/>
+            <a:off x="4206240" y="4480560"/>
             <a:ext cx="3566160" cy="2011680"/>
           </a:xfrm>
           <a:prstGeom prst="roundRect">
@@ -4218,7 +4218,7 @@
         </p:nvSpPr>
         <p:spPr>
           <a:xfrm>
-            <a:off x="4297680" y="4297680"/>
+            <a:off x="4297680" y="4572000"/>
             <a:ext cx="3383280" cy="365760"/>
           </a:xfrm>
           <a:prstGeom prst="roundRect">
@@ -4263,7 +4263,7 @@
         </p:nvSpPr>
         <p:spPr>
           <a:xfrm>
-            <a:off x="4343400" y="4343400"/>
+            <a:off x="4343400" y="4617720"/>
             <a:ext cx="3291840" cy="274320"/>
           </a:xfrm>
           <a:prstGeom prst="rect">
@@ -4298,7 +4298,7 @@
         </p:nvSpPr>
         <p:spPr>
           <a:xfrm>
-            <a:off x="4343400" y="4709160"/>
+            <a:off x="4343400" y="4983480"/>
             <a:ext cx="3291840" cy="1371600"/>
           </a:xfrm>
           <a:prstGeom prst="rect">
@@ -4341,7 +4341,7 @@
         </p:nvSpPr>
         <p:spPr>
           <a:xfrm>
-            <a:off x="8046720" y="4206240"/>
+            <a:off x="8046720" y="4480560"/>
             <a:ext cx="3566160" cy="2011680"/>
           </a:xfrm>
           <a:prstGeom prst="roundRect">
@@ -4386,7 +4386,7 @@
         </p:nvSpPr>
         <p:spPr>
           <a:xfrm>
-            <a:off x="8138160" y="4297680"/>
+            <a:off x="8138160" y="4572000"/>
             <a:ext cx="3383280" cy="365760"/>
           </a:xfrm>
           <a:prstGeom prst="roundRect">
@@ -4431,7 +4431,7 @@
         </p:nvSpPr>
         <p:spPr>
           <a:xfrm>
-            <a:off x="8183880" y="4343400"/>
+            <a:off x="8183880" y="4617720"/>
             <a:ext cx="3291840" cy="274320"/>
           </a:xfrm>
           <a:prstGeom prst="rect">
@@ -4466,7 +4466,7 @@
         </p:nvSpPr>
         <p:spPr>
           <a:xfrm>
-            <a:off x="8183880" y="4709160"/>
+            <a:off x="8183880" y="4983480"/>
             <a:ext cx="3291840" cy="1371600"/>
           </a:xfrm>
           <a:prstGeom prst="rect">
@@ -4621,22 +4621,22 @@
         </p:nvSpPr>
         <p:spPr>
           <a:xfrm>
-            <a:off x="914400" y="1097280"/>
-            <a:ext cx="10058400" cy="731520"/>
-          </a:xfrm>
-          <a:prstGeom prst="rect">
-            <a:avLst/>
-          </a:prstGeom>
-          <a:noFill/>
-        </p:spPr>
-        <p:txBody>
-          <a:bodyPr wrap="square">
-            <a:spAutoFit/>
-          </a:bodyPr>
-          <a:lstStyle/>
-          <a:p>
-            <a:pPr algn="l">
-              <a:defRPr sz="3600" b="1">
+            <a:off x="914400" y="914400"/>
+            <a:ext cx="10058400" cy="594360"/>
+          </a:xfrm>
+          <a:prstGeom prst="rect">
+            <a:avLst/>
+          </a:prstGeom>
+          <a:noFill/>
+        </p:spPr>
+        <p:txBody>
+          <a:bodyPr wrap="square">
+            <a:spAutoFit/>
+          </a:bodyPr>
+          <a:lstStyle/>
+          <a:p>
+            <a:pPr algn="l">
+              <a:defRPr sz="3200" b="1">
                 <a:solidFill>
                   <a:srgbClr val="FFFFFF"/>
                 </a:solidFill>
@@ -4656,7 +4656,7 @@
         </p:nvSpPr>
         <p:spPr>
           <a:xfrm>
-            <a:off x="548640" y="2011680"/>
+            <a:off x="548640" y="2286000"/>
             <a:ext cx="5394960" cy="685800"/>
           </a:xfrm>
           <a:prstGeom prst="roundRect">
@@ -4701,7 +4701,7 @@
         </p:nvSpPr>
         <p:spPr>
           <a:xfrm>
-            <a:off x="685800" y="2121408"/>
+            <a:off x="685800" y="2395728"/>
             <a:ext cx="457200" cy="365760"/>
           </a:xfrm>
           <a:prstGeom prst="rect">
@@ -4736,7 +4736,7 @@
         </p:nvSpPr>
         <p:spPr>
           <a:xfrm>
-            <a:off x="1097280" y="2057400"/>
+            <a:off x="1097280" y="2331720"/>
             <a:ext cx="2743200" cy="320040"/>
           </a:xfrm>
           <a:prstGeom prst="rect">
@@ -4771,7 +4771,7 @@
         </p:nvSpPr>
         <p:spPr>
           <a:xfrm>
-            <a:off x="1097280" y="2377440"/>
+            <a:off x="1097280" y="2651760"/>
             <a:ext cx="2743200" cy="274320"/>
           </a:xfrm>
           <a:prstGeom prst="rect">
@@ -4806,7 +4806,7 @@
         </p:nvSpPr>
         <p:spPr>
           <a:xfrm>
-            <a:off x="6309360" y="2011680"/>
+            <a:off x="6309360" y="2286000"/>
             <a:ext cx="5394960" cy="685800"/>
           </a:xfrm>
           <a:prstGeom prst="roundRect">
@@ -4851,7 +4851,7 @@
         </p:nvSpPr>
         <p:spPr>
           <a:xfrm>
-            <a:off x="6446520" y="2121408"/>
+            <a:off x="6446520" y="2395728"/>
             <a:ext cx="457200" cy="365760"/>
           </a:xfrm>
           <a:prstGeom prst="rect">
@@ -4886,7 +4886,7 @@
         </p:nvSpPr>
         <p:spPr>
           <a:xfrm>
-            <a:off x="6858000" y="2057400"/>
+            <a:off x="6858000" y="2331720"/>
             <a:ext cx="2743200" cy="320040"/>
           </a:xfrm>
           <a:prstGeom prst="rect">
@@ -4921,7 +4921,7 @@
         </p:nvSpPr>
         <p:spPr>
           <a:xfrm>
-            <a:off x="6858000" y="2377440"/>
+            <a:off x="6858000" y="2651760"/>
             <a:ext cx="2743200" cy="274320"/>
           </a:xfrm>
           <a:prstGeom prst="rect">
@@ -4956,7 +4956,7 @@
         </p:nvSpPr>
         <p:spPr>
           <a:xfrm>
-            <a:off x="548640" y="2880360"/>
+            <a:off x="548640" y="3154680"/>
             <a:ext cx="5394960" cy="685800"/>
           </a:xfrm>
           <a:prstGeom prst="roundRect">
@@ -5001,7 +5001,7 @@
         </p:nvSpPr>
         <p:spPr>
           <a:xfrm>
-            <a:off x="685800" y="2990088"/>
+            <a:off x="685800" y="3264408"/>
             <a:ext cx="457200" cy="365760"/>
           </a:xfrm>
           <a:prstGeom prst="rect">
@@ -5036,7 +5036,7 @@
         </p:nvSpPr>
         <p:spPr>
           <a:xfrm>
-            <a:off x="1097280" y="2926080"/>
+            <a:off x="1097280" y="3200400"/>
             <a:ext cx="2743200" cy="320040"/>
           </a:xfrm>
           <a:prstGeom prst="rect">
@@ -5071,7 +5071,7 @@
         </p:nvSpPr>
         <p:spPr>
           <a:xfrm>
-            <a:off x="1097280" y="3246120"/>
+            <a:off x="1097280" y="3520440"/>
             <a:ext cx="2743200" cy="274320"/>
           </a:xfrm>
           <a:prstGeom prst="rect">
@@ -5106,7 +5106,7 @@
         </p:nvSpPr>
         <p:spPr>
           <a:xfrm>
-            <a:off x="6309360" y="2880360"/>
+            <a:off x="6309360" y="3154680"/>
             <a:ext cx="5394960" cy="685800"/>
           </a:xfrm>
           <a:prstGeom prst="roundRect">
@@ -5151,7 +5151,7 @@
         </p:nvSpPr>
         <p:spPr>
           <a:xfrm>
-            <a:off x="6446520" y="2990088"/>
+            <a:off x="6446520" y="3264408"/>
             <a:ext cx="457200" cy="365760"/>
           </a:xfrm>
           <a:prstGeom prst="rect">
@@ -5186,7 +5186,7 @@
         </p:nvSpPr>
         <p:spPr>
           <a:xfrm>
-            <a:off x="6858000" y="2926080"/>
+            <a:off x="6858000" y="3200400"/>
             <a:ext cx="2743200" cy="320040"/>
           </a:xfrm>
           <a:prstGeom prst="rect">
@@ -5221,7 +5221,7 @@
         </p:nvSpPr>
         <p:spPr>
           <a:xfrm>
-            <a:off x="6858000" y="3246120"/>
+            <a:off x="6858000" y="3520440"/>
             <a:ext cx="2743200" cy="274320"/>
           </a:xfrm>
           <a:prstGeom prst="rect">
@@ -5256,7 +5256,7 @@
         </p:nvSpPr>
         <p:spPr>
           <a:xfrm>
-            <a:off x="548640" y="3749040"/>
+            <a:off x="548640" y="4023360"/>
             <a:ext cx="5394960" cy="685800"/>
           </a:xfrm>
           <a:prstGeom prst="roundRect">
@@ -5301,7 +5301,7 @@
         </p:nvSpPr>
         <p:spPr>
           <a:xfrm>
-            <a:off x="685800" y="3858768"/>
+            <a:off x="685800" y="4133088"/>
             <a:ext cx="457200" cy="365760"/>
           </a:xfrm>
           <a:prstGeom prst="rect">
@@ -5336,7 +5336,7 @@
         </p:nvSpPr>
         <p:spPr>
           <a:xfrm>
-            <a:off x="1097280" y="3794760"/>
+            <a:off x="1097280" y="4069080"/>
             <a:ext cx="2743200" cy="320040"/>
           </a:xfrm>
           <a:prstGeom prst="rect">
@@ -5371,7 +5371,7 @@
         </p:nvSpPr>
         <p:spPr>
           <a:xfrm>
-            <a:off x="1097280" y="4114800"/>
+            <a:off x="1097280" y="4389120"/>
             <a:ext cx="2743200" cy="274320"/>
           </a:xfrm>
           <a:prstGeom prst="rect">
@@ -5406,7 +5406,7 @@
         </p:nvSpPr>
         <p:spPr>
           <a:xfrm>
-            <a:off x="6309360" y="3749040"/>
+            <a:off x="6309360" y="4023360"/>
             <a:ext cx="5394960" cy="685800"/>
           </a:xfrm>
           <a:prstGeom prst="roundRect">
@@ -5451,7 +5451,7 @@
         </p:nvSpPr>
         <p:spPr>
           <a:xfrm>
-            <a:off x="6446520" y="3858768"/>
+            <a:off x="6446520" y="4133088"/>
             <a:ext cx="457200" cy="365760"/>
           </a:xfrm>
           <a:prstGeom prst="rect">
@@ -5486,7 +5486,7 @@
         </p:nvSpPr>
         <p:spPr>
           <a:xfrm>
-            <a:off x="6858000" y="3794760"/>
+            <a:off x="6858000" y="4069080"/>
             <a:ext cx="2743200" cy="320040"/>
           </a:xfrm>
           <a:prstGeom prst="rect">
@@ -5521,7 +5521,7 @@
         </p:nvSpPr>
         <p:spPr>
           <a:xfrm>
-            <a:off x="6858000" y="4114800"/>
+            <a:off x="6858000" y="4389120"/>
             <a:ext cx="2743200" cy="274320"/>
           </a:xfrm>
           <a:prstGeom prst="rect">
@@ -5556,7 +5556,7 @@
         </p:nvSpPr>
         <p:spPr>
           <a:xfrm>
-            <a:off x="548640" y="4617720"/>
+            <a:off x="548640" y="4892040"/>
             <a:ext cx="5394960" cy="685800"/>
           </a:xfrm>
           <a:prstGeom prst="roundRect">
@@ -5601,7 +5601,7 @@
         </p:nvSpPr>
         <p:spPr>
           <a:xfrm>
-            <a:off x="685800" y="4727448"/>
+            <a:off x="685800" y="5001768"/>
             <a:ext cx="457200" cy="365760"/>
           </a:xfrm>
           <a:prstGeom prst="rect">
@@ -5636,7 +5636,7 @@
         </p:nvSpPr>
         <p:spPr>
           <a:xfrm>
-            <a:off x="1097280" y="4663440"/>
+            <a:off x="1097280" y="4937760"/>
             <a:ext cx="2743200" cy="320040"/>
           </a:xfrm>
           <a:prstGeom prst="rect">
@@ -5671,7 +5671,7 @@
         </p:nvSpPr>
         <p:spPr>
           <a:xfrm>
-            <a:off x="1097280" y="4983480"/>
+            <a:off x="1097280" y="5257800"/>
             <a:ext cx="2743200" cy="274320"/>
           </a:xfrm>
           <a:prstGeom prst="rect">
@@ -5706,7 +5706,7 @@
         </p:nvSpPr>
         <p:spPr>
           <a:xfrm>
-            <a:off x="6309360" y="4617720"/>
+            <a:off x="6309360" y="4892040"/>
             <a:ext cx="5394960" cy="685800"/>
           </a:xfrm>
           <a:prstGeom prst="roundRect">
@@ -5751,7 +5751,7 @@
         </p:nvSpPr>
         <p:spPr>
           <a:xfrm>
-            <a:off x="6446520" y="4727448"/>
+            <a:off x="6446520" y="5001768"/>
             <a:ext cx="457200" cy="365760"/>
           </a:xfrm>
           <a:prstGeom prst="rect">
@@ -5786,7 +5786,7 @@
         </p:nvSpPr>
         <p:spPr>
           <a:xfrm>
-            <a:off x="6858000" y="4663440"/>
+            <a:off x="6858000" y="4937760"/>
             <a:ext cx="2743200" cy="320040"/>
           </a:xfrm>
           <a:prstGeom prst="rect">
@@ -5821,7 +5821,7 @@
         </p:nvSpPr>
         <p:spPr>
           <a:xfrm>
-            <a:off x="6858000" y="4983480"/>
+            <a:off x="6858000" y="5257800"/>
             <a:ext cx="2743200" cy="274320"/>
           </a:xfrm>
           <a:prstGeom prst="rect">
@@ -5856,7 +5856,7 @@
         </p:nvSpPr>
         <p:spPr>
           <a:xfrm>
-            <a:off x="548640" y="5486400"/>
+            <a:off x="548640" y="5760720"/>
             <a:ext cx="5394960" cy="685800"/>
           </a:xfrm>
           <a:prstGeom prst="roundRect">
@@ -5901,7 +5901,7 @@
         </p:nvSpPr>
         <p:spPr>
           <a:xfrm>
-            <a:off x="685800" y="5596128"/>
+            <a:off x="685800" y="5870448"/>
             <a:ext cx="457200" cy="365760"/>
           </a:xfrm>
           <a:prstGeom prst="rect">
@@ -5936,7 +5936,7 @@
         </p:nvSpPr>
         <p:spPr>
           <a:xfrm>
-            <a:off x="1097280" y="5532120"/>
+            <a:off x="1097280" y="5806440"/>
             <a:ext cx="2743200" cy="320040"/>
           </a:xfrm>
           <a:prstGeom prst="rect">
@@ -5971,7 +5971,7 @@
         </p:nvSpPr>
         <p:spPr>
           <a:xfrm>
-            <a:off x="1097280" y="5852160"/>
+            <a:off x="1097280" y="6126480"/>
             <a:ext cx="2743200" cy="274320"/>
           </a:xfrm>
           <a:prstGeom prst="rect">
@@ -6006,7 +6006,7 @@
         </p:nvSpPr>
         <p:spPr>
           <a:xfrm>
-            <a:off x="6309360" y="5486400"/>
+            <a:off x="6309360" y="5760720"/>
             <a:ext cx="5394960" cy="685800"/>
           </a:xfrm>
           <a:prstGeom prst="roundRect">
@@ -6051,7 +6051,7 @@
         </p:nvSpPr>
         <p:spPr>
           <a:xfrm>
-            <a:off x="6446520" y="5596128"/>
+            <a:off x="6446520" y="5870448"/>
             <a:ext cx="457200" cy="365760"/>
           </a:xfrm>
           <a:prstGeom prst="rect">
@@ -6086,7 +6086,7 @@
         </p:nvSpPr>
         <p:spPr>
           <a:xfrm>
-            <a:off x="6858000" y="5532120"/>
+            <a:off x="6858000" y="5806440"/>
             <a:ext cx="2743200" cy="320040"/>
           </a:xfrm>
           <a:prstGeom prst="rect">
@@ -6121,7 +6121,7 @@
         </p:nvSpPr>
         <p:spPr>
           <a:xfrm>
-            <a:off x="6858000" y="5852160"/>
+            <a:off x="6858000" y="6126480"/>
             <a:ext cx="2743200" cy="274320"/>
           </a:xfrm>
           <a:prstGeom prst="rect">
@@ -6268,22 +6268,22 @@
         </p:nvSpPr>
         <p:spPr>
           <a:xfrm>
-            <a:off x="914400" y="1097280"/>
-            <a:ext cx="10058400" cy="731520"/>
-          </a:xfrm>
-          <a:prstGeom prst="rect">
-            <a:avLst/>
-          </a:prstGeom>
-          <a:noFill/>
-        </p:spPr>
-        <p:txBody>
-          <a:bodyPr wrap="square">
-            <a:spAutoFit/>
-          </a:bodyPr>
-          <a:lstStyle/>
-          <a:p>
-            <a:pPr algn="l">
-              <a:defRPr sz="3600" b="1">
+            <a:off x="914400" y="914400"/>
+            <a:ext cx="10058400" cy="594360"/>
+          </a:xfrm>
+          <a:prstGeom prst="rect">
+            <a:avLst/>
+          </a:prstGeom>
+          <a:noFill/>
+        </p:spPr>
+        <p:txBody>
+          <a:bodyPr wrap="square">
+            <a:spAutoFit/>
+          </a:bodyPr>
+          <a:lstStyle/>
+          <a:p>
+            <a:pPr algn="l">
+              <a:defRPr sz="3200" b="1">
                 <a:solidFill>
                   <a:srgbClr val="FFFFFF"/>
                 </a:solidFill>
@@ -6303,22 +6303,22 @@
         </p:nvSpPr>
         <p:spPr>
           <a:xfrm>
-            <a:off x="914400" y="1828800"/>
-            <a:ext cx="10058400" cy="457200"/>
-          </a:xfrm>
-          <a:prstGeom prst="rect">
-            <a:avLst/>
-          </a:prstGeom>
-          <a:noFill/>
-        </p:spPr>
-        <p:txBody>
-          <a:bodyPr wrap="square">
-            <a:spAutoFit/>
-          </a:bodyPr>
-          <a:lstStyle/>
-          <a:p>
-            <a:pPr algn="l">
-              <a:defRPr sz="1800" b="0">
+            <a:off x="914400" y="1600200"/>
+            <a:ext cx="10058400" cy="274320"/>
+          </a:xfrm>
+          <a:prstGeom prst="rect">
+            <a:avLst/>
+          </a:prstGeom>
+          <a:noFill/>
+        </p:spPr>
+        <p:txBody>
+          <a:bodyPr wrap="square">
+            <a:spAutoFit/>
+          </a:bodyPr>
+          <a:lstStyle/>
+          <a:p>
+            <a:pPr algn="l">
+              <a:defRPr sz="1400" b="0">
                 <a:solidFill>
                   <a:srgbClr val="9CA3AF"/>
                 </a:solidFill>
@@ -6330,89 +6330,33 @@
           </a:p>
         </p:txBody>
       </p:sp>
-      <p:sp>
-        <p:nvSpPr>
-          <p:cNvPr id="6" name="Rounded Rectangle 5"/>
-          <p:cNvSpPr/>
-          <p:nvPr/>
-        </p:nvSpPr>
-        <p:spPr>
-          <a:xfrm>
-            <a:off x="457200" y="2011680"/>
-            <a:ext cx="5303520" cy="4114800"/>
-          </a:xfrm>
-          <a:prstGeom prst="roundRect">
-            <a:avLst/>
-          </a:prstGeom>
-          <a:solidFill>
-            <a:srgbClr val="1A2040"/>
-          </a:solidFill>
-          <a:ln w="12700">
-            <a:solidFill>
-              <a:srgbClr val="9CA3AF"/>
-            </a:solidFill>
-          </a:ln>
-        </p:spPr>
-        <p:style>
-          <a:lnRef idx="1">
-            <a:schemeClr val="accent1"/>
-          </a:lnRef>
-          <a:fillRef idx="3">
-            <a:schemeClr val="accent1"/>
-          </a:fillRef>
-          <a:effectRef idx="2">
-            <a:schemeClr val="accent1"/>
-          </a:effectRef>
-          <a:fontRef idx="minor">
-            <a:schemeClr val="lt1"/>
-          </a:fontRef>
-        </p:style>
-        <p:txBody>
-          <a:bodyPr rtlCol="0" anchor="ctr"/>
-          <a:lstStyle/>
-          <a:p>
-            <a:pPr algn="ctr"/>
-          </a:p>
-        </p:txBody>
-      </p:sp>
-      <p:sp>
-        <p:nvSpPr>
-          <p:cNvPr id="7" name="TextBox 6"/>
-          <p:cNvSpPr txBox="1"/>
-          <p:nvPr/>
-        </p:nvSpPr>
-        <p:spPr>
-          <a:xfrm>
-            <a:off x="457200" y="3200400"/>
-            <a:ext cx="5303520" cy="914400"/>
-          </a:xfrm>
-          <a:prstGeom prst="rect">
-            <a:avLst/>
-          </a:prstGeom>
-          <a:noFill/>
-        </p:spPr>
-        <p:txBody>
-          <a:bodyPr wrap="square">
-            <a:spAutoFit/>
-          </a:bodyPr>
-          <a:lstStyle/>
-          <a:p>
-            <a:pPr algn="ctr">
-              <a:defRPr sz="1600" b="0">
-                <a:solidFill>
-                  <a:srgbClr val="9CA3AF"/>
-                </a:solidFill>
-              </a:defRPr>
-            </a:pPr>
-            <a:r>
-              <a:t>[ Source Image ]</a:t>
-            </a:r>
-          </a:p>
-        </p:txBody>
-      </p:sp>
-      <p:sp>
-        <p:nvSpPr>
-          <p:cNvPr id="8" name="Rounded Rectangle 7"/>
+      <p:pic>
+        <p:nvPicPr>
+          <p:cNvPr id="6" name="Picture 5" descr="7404c9dac94543b1b713573cb9a268e0_HELMET_MISSING_001.png"/>
+          <p:cNvPicPr>
+            <a:picLocks noChangeAspect="1"/>
+          </p:cNvPicPr>
+          <p:nvPr/>
+        </p:nvPicPr>
+        <p:blipFill>
+          <a:blip r:embed="rId2"/>
+          <a:stretch>
+            <a:fillRect/>
+          </a:stretch>
+        </p:blipFill>
+        <p:spPr>
+          <a:xfrm>
+            <a:off x="457200" y="2194560"/>
+            <a:ext cx="5303520" cy="4023360"/>
+          </a:xfrm>
+          <a:prstGeom prst="rect">
+            <a:avLst/>
+          </a:prstGeom>
+        </p:spPr>
+      </p:pic>
+      <p:sp>
+        <p:nvSpPr>
+          <p:cNvPr id="7" name="Rounded Rectangle 6"/>
           <p:cNvSpPr/>
           <p:nvPr/>
         </p:nvSpPr>
@@ -6466,22 +6410,22 @@
       </p:sp>
       <p:pic>
         <p:nvPicPr>
-          <p:cNvPr id="9" name="Picture 8" descr="HELMET_MISSING_001_evidence_20260621_114044_989889.jpg"/>
+          <p:cNvPr id="8" name="Picture 7" descr="HELMET_MISSING_001_evidence_20260620_230253_645104.jpg"/>
           <p:cNvPicPr>
             <a:picLocks noChangeAspect="1"/>
           </p:cNvPicPr>
           <p:nvPr/>
         </p:nvPicPr>
         <p:blipFill>
-          <a:blip r:embed="rId2"/>
+          <a:blip r:embed="rId3"/>
           <a:stretch>
             <a:fillRect/>
           </a:stretch>
         </p:blipFill>
         <p:spPr>
           <a:xfrm>
-            <a:off x="6217920" y="2011680"/>
-            <a:ext cx="5303520" cy="4114800"/>
+            <a:off x="6217920" y="2194560"/>
+            <a:ext cx="5303520" cy="4023360"/>
           </a:xfrm>
           <a:prstGeom prst="rect">
             <a:avLst/>
@@ -6490,7 +6434,7 @@
       </p:pic>
       <p:sp>
         <p:nvSpPr>
-          <p:cNvPr id="10" name="Rounded Rectangle 9"/>
+          <p:cNvPr id="9" name="Rounded Rectangle 8"/>
           <p:cNvSpPr/>
           <p:nvPr/>
         </p:nvSpPr>
@@ -6544,13 +6488,13 @@
       </p:sp>
       <p:sp>
         <p:nvSpPr>
-          <p:cNvPr id="11" name="Rounded Rectangle 10"/>
+          <p:cNvPr id="10" name="Rounded Rectangle 9"/>
           <p:cNvSpPr/>
           <p:nvPr/>
         </p:nvSpPr>
         <p:spPr>
           <a:xfrm>
-            <a:off x="7772400" y="2103120"/>
+            <a:off x="7772400" y="2286000"/>
             <a:ext cx="3474720" cy="1280160"/>
           </a:xfrm>
           <a:prstGeom prst="roundRect">
@@ -6589,13 +6533,48 @@
       </p:sp>
       <p:sp>
         <p:nvSpPr>
+          <p:cNvPr id="11" name="TextBox 10"/>
+          <p:cNvSpPr txBox="1"/>
+          <p:nvPr/>
+        </p:nvSpPr>
+        <p:spPr>
+          <a:xfrm>
+            <a:off x="7863840" y="2331720"/>
+            <a:ext cx="3291840" cy="274320"/>
+          </a:xfrm>
+          <a:prstGeom prst="rect">
+            <a:avLst/>
+          </a:prstGeom>
+          <a:noFill/>
+        </p:spPr>
+        <p:txBody>
+          <a:bodyPr wrap="square">
+            <a:spAutoFit/>
+          </a:bodyPr>
+          <a:lstStyle/>
+          <a:p>
+            <a:pPr algn="l">
+              <a:defRPr sz="1000" b="1">
+                <a:solidFill>
+                  <a:srgbClr val="FFFFFF"/>
+                </a:solidFill>
+              </a:defRPr>
+            </a:pPr>
+            <a:r>
+              <a:t>Motorcycle rider without helmet.</a:t>
+            </a:r>
+          </a:p>
+        </p:txBody>
+      </p:sp>
+      <p:sp>
+        <p:nvSpPr>
           <p:cNvPr id="12" name="TextBox 11"/>
           <p:cNvSpPr txBox="1"/>
           <p:nvPr/>
         </p:nvSpPr>
         <p:spPr>
           <a:xfrm>
-            <a:off x="7863840" y="2148840"/>
+            <a:off x="7863840" y="2651760"/>
             <a:ext cx="3291840" cy="274320"/>
           </a:xfrm>
           <a:prstGeom prst="rect">
@@ -6610,14 +6589,14 @@
           <a:lstStyle/>
           <a:p>
             <a:pPr algn="l">
-              <a:defRPr sz="1000" b="1">
-                <a:solidFill>
-                  <a:srgbClr val="FFFFFF"/>
-                </a:solidFill>
-              </a:defRPr>
-            </a:pPr>
-            <a:r>
-              <a:t>Motorcycle rider without helmet.</a:t>
+              <a:defRPr sz="1000" b="0">
+                <a:solidFill>
+                  <a:srgbClr val="9CA3AF"/>
+                </a:solidFill>
+              </a:defRPr>
+            </a:pPr>
+            <a:r>
+              <a:t>Confidence: 87% | Risk: 30</a:t>
             </a:r>
           </a:p>
         </p:txBody>
@@ -6625,41 +6604,6 @@
       <p:sp>
         <p:nvSpPr>
           <p:cNvPr id="13" name="TextBox 12"/>
-          <p:cNvSpPr txBox="1"/>
-          <p:nvPr/>
-        </p:nvSpPr>
-        <p:spPr>
-          <a:xfrm>
-            <a:off x="7863840" y="2468880"/>
-            <a:ext cx="3291840" cy="274320"/>
-          </a:xfrm>
-          <a:prstGeom prst="rect">
-            <a:avLst/>
-          </a:prstGeom>
-          <a:noFill/>
-        </p:spPr>
-        <p:txBody>
-          <a:bodyPr wrap="square">
-            <a:spAutoFit/>
-          </a:bodyPr>
-          <a:lstStyle/>
-          <a:p>
-            <a:pPr algn="l">
-              <a:defRPr sz="1000" b="0">
-                <a:solidFill>
-                  <a:srgbClr val="9CA3AF"/>
-                </a:solidFill>
-              </a:defRPr>
-            </a:pPr>
-            <a:r>
-              <a:t>Confidence: 87% | Risk: 30</a:t>
-            </a:r>
-          </a:p>
-        </p:txBody>
-      </p:sp>
-      <p:sp>
-        <p:nvSpPr>
-          <p:cNvPr id="14" name="TextBox 13"/>
           <p:cNvSpPr txBox="1"/>
           <p:nvPr/>
         </p:nvSpPr>
@@ -6694,7 +6638,7 @@
       </p:sp>
       <p:sp>
         <p:nvSpPr>
-          <p:cNvPr id="15" name="TextBox 14"/>
+          <p:cNvPr id="14" name="TextBox 13"/>
           <p:cNvSpPr txBox="1"/>
           <p:nvPr/>
         </p:nvSpPr>
@@ -6729,7 +6673,7 @@
       </p:sp>
       <p:sp>
         <p:nvSpPr>
-          <p:cNvPr id="16" name="TextBox 15"/>
+          <p:cNvPr id="15" name="TextBox 14"/>
           <p:cNvSpPr txBox="1"/>
           <p:nvPr/>
         </p:nvSpPr>
@@ -6764,7 +6708,7 @@
       </p:sp>
       <p:sp>
         <p:nvSpPr>
-          <p:cNvPr id="17" name="TextBox 16"/>
+          <p:cNvPr id="16" name="TextBox 15"/>
           <p:cNvSpPr txBox="1"/>
           <p:nvPr/>
         </p:nvSpPr>
@@ -6799,7 +6743,7 @@
       </p:sp>
       <p:sp>
         <p:nvSpPr>
-          <p:cNvPr id="18" name="TextBox 17"/>
+          <p:cNvPr id="17" name="TextBox 16"/>
           <p:cNvSpPr txBox="1"/>
           <p:nvPr/>
         </p:nvSpPr>
@@ -6952,22 +6896,22 @@
         </p:nvSpPr>
         <p:spPr>
           <a:xfrm>
-            <a:off x="914400" y="1097280"/>
-            <a:ext cx="10058400" cy="731520"/>
-          </a:xfrm>
-          <a:prstGeom prst="rect">
-            <a:avLst/>
-          </a:prstGeom>
-          <a:noFill/>
-        </p:spPr>
-        <p:txBody>
-          <a:bodyPr wrap="square">
-            <a:spAutoFit/>
-          </a:bodyPr>
-          <a:lstStyle/>
-          <a:p>
-            <a:pPr algn="l">
-              <a:defRPr sz="3600" b="1">
+            <a:off x="914400" y="914400"/>
+            <a:ext cx="10058400" cy="594360"/>
+          </a:xfrm>
+          <a:prstGeom prst="rect">
+            <a:avLst/>
+          </a:prstGeom>
+          <a:noFill/>
+        </p:spPr>
+        <p:txBody>
+          <a:bodyPr wrap="square">
+            <a:spAutoFit/>
+          </a:bodyPr>
+          <a:lstStyle/>
+          <a:p>
+            <a:pPr algn="l">
+              <a:defRPr sz="3200" b="1">
                 <a:solidFill>
                   <a:srgbClr val="FFFFFF"/>
                 </a:solidFill>
@@ -6987,22 +6931,22 @@
         </p:nvSpPr>
         <p:spPr>
           <a:xfrm>
-            <a:off x="914400" y="1828800"/>
-            <a:ext cx="10058400" cy="457200"/>
-          </a:xfrm>
-          <a:prstGeom prst="rect">
-            <a:avLst/>
-          </a:prstGeom>
-          <a:noFill/>
-        </p:spPr>
-        <p:txBody>
-          <a:bodyPr wrap="square">
-            <a:spAutoFit/>
-          </a:bodyPr>
-          <a:lstStyle/>
-          <a:p>
-            <a:pPr algn="l">
-              <a:defRPr sz="1800" b="0">
+            <a:off x="914400" y="1600200"/>
+            <a:ext cx="10058400" cy="274320"/>
+          </a:xfrm>
+          <a:prstGeom prst="rect">
+            <a:avLst/>
+          </a:prstGeom>
+          <a:noFill/>
+        </p:spPr>
+        <p:txBody>
+          <a:bodyPr wrap="square">
+            <a:spAutoFit/>
+          </a:bodyPr>
+          <a:lstStyle/>
+          <a:p>
+            <a:pPr algn="l">
+              <a:defRPr sz="1400" b="0">
                 <a:solidFill>
                   <a:srgbClr val="9CA3AF"/>
                 </a:solidFill>
@@ -7014,89 +6958,33 @@
           </a:p>
         </p:txBody>
       </p:sp>
-      <p:sp>
-        <p:nvSpPr>
-          <p:cNvPr id="6" name="Rounded Rectangle 5"/>
-          <p:cNvSpPr/>
-          <p:nvPr/>
-        </p:nvSpPr>
-        <p:spPr>
-          <a:xfrm>
-            <a:off x="457200" y="2011680"/>
-            <a:ext cx="5303520" cy="4114800"/>
-          </a:xfrm>
-          <a:prstGeom prst="roundRect">
-            <a:avLst/>
-          </a:prstGeom>
-          <a:solidFill>
-            <a:srgbClr val="1A2040"/>
-          </a:solidFill>
-          <a:ln w="12700">
-            <a:solidFill>
-              <a:srgbClr val="9CA3AF"/>
-            </a:solidFill>
-          </a:ln>
-        </p:spPr>
-        <p:style>
-          <a:lnRef idx="1">
-            <a:schemeClr val="accent1"/>
-          </a:lnRef>
-          <a:fillRef idx="3">
-            <a:schemeClr val="accent1"/>
-          </a:fillRef>
-          <a:effectRef idx="2">
-            <a:schemeClr val="accent1"/>
-          </a:effectRef>
-          <a:fontRef idx="minor">
-            <a:schemeClr val="lt1"/>
-          </a:fontRef>
-        </p:style>
-        <p:txBody>
-          <a:bodyPr rtlCol="0" anchor="ctr"/>
-          <a:lstStyle/>
-          <a:p>
-            <a:pPr algn="ctr"/>
-          </a:p>
-        </p:txBody>
-      </p:sp>
-      <p:sp>
-        <p:nvSpPr>
-          <p:cNvPr id="7" name="TextBox 6"/>
-          <p:cNvSpPr txBox="1"/>
-          <p:nvPr/>
-        </p:nvSpPr>
-        <p:spPr>
-          <a:xfrm>
-            <a:off x="457200" y="3200400"/>
-            <a:ext cx="5303520" cy="914400"/>
-          </a:xfrm>
-          <a:prstGeom prst="rect">
-            <a:avLst/>
-          </a:prstGeom>
-          <a:noFill/>
-        </p:spPr>
-        <p:txBody>
-          <a:bodyPr wrap="square">
-            <a:spAutoFit/>
-          </a:bodyPr>
-          <a:lstStyle/>
-          <a:p>
-            <a:pPr algn="ctr">
-              <a:defRPr sz="1600" b="0">
-                <a:solidFill>
-                  <a:srgbClr val="9CA3AF"/>
-                </a:solidFill>
-              </a:defRPr>
-            </a:pPr>
-            <a:r>
-              <a:t>[ Source Image ]</a:t>
-            </a:r>
-          </a:p>
-        </p:txBody>
-      </p:sp>
-      <p:sp>
-        <p:nvSpPr>
-          <p:cNvPr id="8" name="Rounded Rectangle 7"/>
+      <p:pic>
+        <p:nvPicPr>
+          <p:cNvPr id="6" name="Picture 5" descr="e6a92a02d13a4cd5b2b3cc2b56f03672_TRIPLE_RIDING_001.jpeg"/>
+          <p:cNvPicPr>
+            <a:picLocks noChangeAspect="1"/>
+          </p:cNvPicPr>
+          <p:nvPr/>
+        </p:nvPicPr>
+        <p:blipFill>
+          <a:blip r:embed="rId2"/>
+          <a:stretch>
+            <a:fillRect/>
+          </a:stretch>
+        </p:blipFill>
+        <p:spPr>
+          <a:xfrm>
+            <a:off x="457200" y="2194560"/>
+            <a:ext cx="5303520" cy="4023360"/>
+          </a:xfrm>
+          <a:prstGeom prst="rect">
+            <a:avLst/>
+          </a:prstGeom>
+        </p:spPr>
+      </p:pic>
+      <p:sp>
+        <p:nvSpPr>
+          <p:cNvPr id="7" name="Rounded Rectangle 6"/>
           <p:cNvSpPr/>
           <p:nvPr/>
         </p:nvSpPr>
@@ -7150,22 +7038,22 @@
       </p:sp>
       <p:pic>
         <p:nvPicPr>
-          <p:cNvPr id="9" name="Picture 8" descr="TRIPLE_RIDING_001_evidence_20260621_114051_548694.jpg"/>
+          <p:cNvPr id="8" name="Picture 7" descr="TRIPLE_RIDING_001_evidence_20260620_230451_858878.jpg"/>
           <p:cNvPicPr>
             <a:picLocks noChangeAspect="1"/>
           </p:cNvPicPr>
           <p:nvPr/>
         </p:nvPicPr>
         <p:blipFill>
-          <a:blip r:embed="rId2"/>
+          <a:blip r:embed="rId3"/>
           <a:stretch>
             <a:fillRect/>
           </a:stretch>
         </p:blipFill>
         <p:spPr>
           <a:xfrm>
-            <a:off x="6217920" y="2011680"/>
-            <a:ext cx="5303520" cy="4114800"/>
+            <a:off x="6217920" y="2194560"/>
+            <a:ext cx="5303520" cy="4023360"/>
           </a:xfrm>
           <a:prstGeom prst="rect">
             <a:avLst/>
@@ -7174,7 +7062,7 @@
       </p:pic>
       <p:sp>
         <p:nvSpPr>
-          <p:cNvPr id="10" name="Rounded Rectangle 9"/>
+          <p:cNvPr id="9" name="Rounded Rectangle 8"/>
           <p:cNvSpPr/>
           <p:nvPr/>
         </p:nvSpPr>
@@ -7228,13 +7116,13 @@
       </p:sp>
       <p:sp>
         <p:nvSpPr>
-          <p:cNvPr id="11" name="Rounded Rectangle 10"/>
+          <p:cNvPr id="10" name="Rounded Rectangle 9"/>
           <p:cNvSpPr/>
           <p:nvPr/>
         </p:nvSpPr>
         <p:spPr>
           <a:xfrm>
-            <a:off x="7772400" y="2103120"/>
+            <a:off x="7772400" y="2286000"/>
             <a:ext cx="3474720" cy="1280160"/>
           </a:xfrm>
           <a:prstGeom prst="roundRect">
@@ -7273,13 +7161,48 @@
       </p:sp>
       <p:sp>
         <p:nvSpPr>
+          <p:cNvPr id="11" name="TextBox 10"/>
+          <p:cNvSpPr txBox="1"/>
+          <p:nvPr/>
+        </p:nvSpPr>
+        <p:spPr>
+          <a:xfrm>
+            <a:off x="7863840" y="2331720"/>
+            <a:ext cx="3291840" cy="274320"/>
+          </a:xfrm>
+          <a:prstGeom prst="rect">
+            <a:avLst/>
+          </a:prstGeom>
+          <a:noFill/>
+        </p:spPr>
+        <p:txBody>
+          <a:bodyPr wrap="square">
+            <a:spAutoFit/>
+          </a:bodyPr>
+          <a:lstStyle/>
+          <a:p>
+            <a:pPr algn="l">
+              <a:defRPr sz="1000" b="1">
+                <a:solidFill>
+                  <a:srgbClr val="FFFFFF"/>
+                </a:solidFill>
+              </a:defRPr>
+            </a:pPr>
+            <a:r>
+              <a:t>3 riders on one motorcycle.</a:t>
+            </a:r>
+          </a:p>
+        </p:txBody>
+      </p:sp>
+      <p:sp>
+        <p:nvSpPr>
           <p:cNvPr id="12" name="TextBox 11"/>
           <p:cNvSpPr txBox="1"/>
           <p:nvPr/>
         </p:nvSpPr>
         <p:spPr>
           <a:xfrm>
-            <a:off x="7863840" y="2148840"/>
+            <a:off x="7863840" y="2651760"/>
             <a:ext cx="3291840" cy="274320"/>
           </a:xfrm>
           <a:prstGeom prst="rect">
@@ -7294,14 +7217,14 @@
           <a:lstStyle/>
           <a:p>
             <a:pPr algn="l">
-              <a:defRPr sz="1000" b="1">
-                <a:solidFill>
-                  <a:srgbClr val="FFFFFF"/>
-                </a:solidFill>
-              </a:defRPr>
-            </a:pPr>
-            <a:r>
-              <a:t>3 riders on one motorcycle.</a:t>
+              <a:defRPr sz="1000" b="0">
+                <a:solidFill>
+                  <a:srgbClr val="9CA3AF"/>
+                </a:solidFill>
+              </a:defRPr>
+            </a:pPr>
+            <a:r>
+              <a:t>Confidence: 89% | Risk: 75</a:t>
             </a:r>
           </a:p>
         </p:txBody>
@@ -7309,41 +7232,6 @@
       <p:sp>
         <p:nvSpPr>
           <p:cNvPr id="13" name="TextBox 12"/>
-          <p:cNvSpPr txBox="1"/>
-          <p:nvPr/>
-        </p:nvSpPr>
-        <p:spPr>
-          <a:xfrm>
-            <a:off x="7863840" y="2468880"/>
-            <a:ext cx="3291840" cy="274320"/>
-          </a:xfrm>
-          <a:prstGeom prst="rect">
-            <a:avLst/>
-          </a:prstGeom>
-          <a:noFill/>
-        </p:spPr>
-        <p:txBody>
-          <a:bodyPr wrap="square">
-            <a:spAutoFit/>
-          </a:bodyPr>
-          <a:lstStyle/>
-          <a:p>
-            <a:pPr algn="l">
-              <a:defRPr sz="1000" b="0">
-                <a:solidFill>
-                  <a:srgbClr val="9CA3AF"/>
-                </a:solidFill>
-              </a:defRPr>
-            </a:pPr>
-            <a:r>
-              <a:t>Confidence: 89% | Risk: 75</a:t>
-            </a:r>
-          </a:p>
-        </p:txBody>
-      </p:sp>
-      <p:sp>
-        <p:nvSpPr>
-          <p:cNvPr id="14" name="TextBox 13"/>
           <p:cNvSpPr txBox="1"/>
           <p:nvPr/>
         </p:nvSpPr>
@@ -7378,7 +7266,7 @@
       </p:sp>
       <p:sp>
         <p:nvSpPr>
-          <p:cNvPr id="15" name="TextBox 14"/>
+          <p:cNvPr id="14" name="TextBox 13"/>
           <p:cNvSpPr txBox="1"/>
           <p:nvPr/>
         </p:nvSpPr>
@@ -7413,7 +7301,7 @@
       </p:sp>
       <p:sp>
         <p:nvSpPr>
-          <p:cNvPr id="16" name="TextBox 15"/>
+          <p:cNvPr id="15" name="TextBox 14"/>
           <p:cNvSpPr txBox="1"/>
           <p:nvPr/>
         </p:nvSpPr>
@@ -7448,7 +7336,7 @@
       </p:sp>
       <p:sp>
         <p:nvSpPr>
-          <p:cNvPr id="17" name="TextBox 16"/>
+          <p:cNvPr id="16" name="TextBox 15"/>
           <p:cNvSpPr txBox="1"/>
           <p:nvPr/>
         </p:nvSpPr>
@@ -7483,7 +7371,7 @@
       </p:sp>
       <p:sp>
         <p:nvSpPr>
-          <p:cNvPr id="18" name="TextBox 17"/>
+          <p:cNvPr id="17" name="TextBox 16"/>
           <p:cNvSpPr txBox="1"/>
           <p:nvPr/>
         </p:nvSpPr>
@@ -7636,22 +7524,22 @@
         </p:nvSpPr>
         <p:spPr>
           <a:xfrm>
-            <a:off x="914400" y="1097280"/>
-            <a:ext cx="10058400" cy="731520"/>
-          </a:xfrm>
-          <a:prstGeom prst="rect">
-            <a:avLst/>
-          </a:prstGeom>
-          <a:noFill/>
-        </p:spPr>
-        <p:txBody>
-          <a:bodyPr wrap="square">
-            <a:spAutoFit/>
-          </a:bodyPr>
-          <a:lstStyle/>
-          <a:p>
-            <a:pPr algn="l">
-              <a:defRPr sz="3600" b="1">
+            <a:off x="914400" y="914400"/>
+            <a:ext cx="10058400" cy="594360"/>
+          </a:xfrm>
+          <a:prstGeom prst="rect">
+            <a:avLst/>
+          </a:prstGeom>
+          <a:noFill/>
+        </p:spPr>
+        <p:txBody>
+          <a:bodyPr wrap="square">
+            <a:spAutoFit/>
+          </a:bodyPr>
+          <a:lstStyle/>
+          <a:p>
+            <a:pPr algn="l">
+              <a:defRPr sz="3200" b="1">
                 <a:solidFill>
                   <a:srgbClr val="FFFFFF"/>
                 </a:solidFill>
@@ -7671,22 +7559,22 @@
         </p:nvSpPr>
         <p:spPr>
           <a:xfrm>
-            <a:off x="914400" y="1828800"/>
-            <a:ext cx="10058400" cy="457200"/>
-          </a:xfrm>
-          <a:prstGeom prst="rect">
-            <a:avLst/>
-          </a:prstGeom>
-          <a:noFill/>
-        </p:spPr>
-        <p:txBody>
-          <a:bodyPr wrap="square">
-            <a:spAutoFit/>
-          </a:bodyPr>
-          <a:lstStyle/>
-          <a:p>
-            <a:pPr algn="l">
-              <a:defRPr sz="1800" b="0">
+            <a:off x="914400" y="1600200"/>
+            <a:ext cx="10058400" cy="274320"/>
+          </a:xfrm>
+          <a:prstGeom prst="rect">
+            <a:avLst/>
+          </a:prstGeom>
+          <a:noFill/>
+        </p:spPr>
+        <p:txBody>
+          <a:bodyPr wrap="square">
+            <a:spAutoFit/>
+          </a:bodyPr>
+          <a:lstStyle/>
+          <a:p>
+            <a:pPr algn="l">
+              <a:defRPr sz="1400" b="0">
                 <a:solidFill>
                   <a:srgbClr val="9CA3AF"/>
                 </a:solidFill>
@@ -7698,89 +7586,33 @@
           </a:p>
         </p:txBody>
       </p:sp>
-      <p:sp>
-        <p:nvSpPr>
-          <p:cNvPr id="6" name="Rounded Rectangle 5"/>
-          <p:cNvSpPr/>
-          <p:nvPr/>
-        </p:nvSpPr>
-        <p:spPr>
-          <a:xfrm>
-            <a:off x="457200" y="2011680"/>
-            <a:ext cx="5303520" cy="4114800"/>
-          </a:xfrm>
-          <a:prstGeom prst="roundRect">
-            <a:avLst/>
-          </a:prstGeom>
-          <a:solidFill>
-            <a:srgbClr val="1A2040"/>
-          </a:solidFill>
-          <a:ln w="12700">
-            <a:solidFill>
-              <a:srgbClr val="9CA3AF"/>
-            </a:solidFill>
-          </a:ln>
-        </p:spPr>
-        <p:style>
-          <a:lnRef idx="1">
-            <a:schemeClr val="accent1"/>
-          </a:lnRef>
-          <a:fillRef idx="3">
-            <a:schemeClr val="accent1"/>
-          </a:fillRef>
-          <a:effectRef idx="2">
-            <a:schemeClr val="accent1"/>
-          </a:effectRef>
-          <a:fontRef idx="minor">
-            <a:schemeClr val="lt1"/>
-          </a:fontRef>
-        </p:style>
-        <p:txBody>
-          <a:bodyPr rtlCol="0" anchor="ctr"/>
-          <a:lstStyle/>
-          <a:p>
-            <a:pPr algn="ctr"/>
-          </a:p>
-        </p:txBody>
-      </p:sp>
-      <p:sp>
-        <p:nvSpPr>
-          <p:cNvPr id="7" name="TextBox 6"/>
-          <p:cNvSpPr txBox="1"/>
-          <p:nvPr/>
-        </p:nvSpPr>
-        <p:spPr>
-          <a:xfrm>
-            <a:off x="457200" y="3200400"/>
-            <a:ext cx="5303520" cy="914400"/>
-          </a:xfrm>
-          <a:prstGeom prst="rect">
-            <a:avLst/>
-          </a:prstGeom>
-          <a:noFill/>
-        </p:spPr>
-        <p:txBody>
-          <a:bodyPr wrap="square">
-            <a:spAutoFit/>
-          </a:bodyPr>
-          <a:lstStyle/>
-          <a:p>
-            <a:pPr algn="ctr">
-              <a:defRPr sz="1600" b="0">
-                <a:solidFill>
-                  <a:srgbClr val="9CA3AF"/>
-                </a:solidFill>
-              </a:defRPr>
-            </a:pPr>
-            <a:r>
-              <a:t>[ Source Image ]</a:t>
-            </a:r>
-          </a:p>
-        </p:txBody>
-      </p:sp>
-      <p:sp>
-        <p:nvSpPr>
-          <p:cNvPr id="8" name="Rounded Rectangle 7"/>
+      <p:pic>
+        <p:nvPicPr>
+          <p:cNvPr id="6" name="Picture 5" descr="ee5f3007f8a94faea3db24c5fe40041b_OVERLOADING_001.jpg"/>
+          <p:cNvPicPr>
+            <a:picLocks noChangeAspect="1"/>
+          </p:cNvPicPr>
+          <p:nvPr/>
+        </p:nvPicPr>
+        <p:blipFill>
+          <a:blip r:embed="rId2"/>
+          <a:stretch>
+            <a:fillRect/>
+          </a:stretch>
+        </p:blipFill>
+        <p:spPr>
+          <a:xfrm>
+            <a:off x="457200" y="2194560"/>
+            <a:ext cx="5303520" cy="4023360"/>
+          </a:xfrm>
+          <a:prstGeom prst="rect">
+            <a:avLst/>
+          </a:prstGeom>
+        </p:spPr>
+      </p:pic>
+      <p:sp>
+        <p:nvSpPr>
+          <p:cNvPr id="7" name="Rounded Rectangle 6"/>
           <p:cNvSpPr/>
           <p:nvPr/>
         </p:nvSpPr>
@@ -7834,22 +7666,22 @@
       </p:sp>
       <p:pic>
         <p:nvPicPr>
-          <p:cNvPr id="9" name="Picture 8" descr="OVERLOADING_001_evidence_20260621_114123_863875.jpg"/>
+          <p:cNvPr id="8" name="Picture 7" descr="OVERLOADING_001_evidence_20260620_230441_349975.jpg"/>
           <p:cNvPicPr>
             <a:picLocks noChangeAspect="1"/>
           </p:cNvPicPr>
           <p:nvPr/>
         </p:nvPicPr>
         <p:blipFill>
-          <a:blip r:embed="rId2"/>
+          <a:blip r:embed="rId3"/>
           <a:stretch>
             <a:fillRect/>
           </a:stretch>
         </p:blipFill>
         <p:spPr>
           <a:xfrm>
-            <a:off x="6217920" y="2011680"/>
-            <a:ext cx="5303520" cy="4114800"/>
+            <a:off x="6217920" y="2194560"/>
+            <a:ext cx="5303520" cy="4023360"/>
           </a:xfrm>
           <a:prstGeom prst="rect">
             <a:avLst/>
@@ -7858,7 +7690,7 @@
       </p:pic>
       <p:sp>
         <p:nvSpPr>
-          <p:cNvPr id="10" name="Rounded Rectangle 9"/>
+          <p:cNvPr id="9" name="Rounded Rectangle 8"/>
           <p:cNvSpPr/>
           <p:nvPr/>
         </p:nvSpPr>
@@ -7912,13 +7744,13 @@
       </p:sp>
       <p:sp>
         <p:nvSpPr>
-          <p:cNvPr id="11" name="Rounded Rectangle 10"/>
+          <p:cNvPr id="10" name="Rounded Rectangle 9"/>
           <p:cNvSpPr/>
           <p:nvPr/>
         </p:nvSpPr>
         <p:spPr>
           <a:xfrm>
-            <a:off x="7772400" y="2103120"/>
+            <a:off x="7772400" y="2286000"/>
             <a:ext cx="3474720" cy="1280160"/>
           </a:xfrm>
           <a:prstGeom prst="roundRect">
@@ -7957,13 +7789,48 @@
       </p:sp>
       <p:sp>
         <p:nvSpPr>
+          <p:cNvPr id="11" name="TextBox 10"/>
+          <p:cNvSpPr txBox="1"/>
+          <p:nvPr/>
+        </p:nvSpPr>
+        <p:spPr>
+          <a:xfrm>
+            <a:off x="7863840" y="2331720"/>
+            <a:ext cx="3291840" cy="274320"/>
+          </a:xfrm>
+          <a:prstGeom prst="rect">
+            <a:avLst/>
+          </a:prstGeom>
+          <a:noFill/>
+        </p:spPr>
+        <p:txBody>
+          <a:bodyPr wrap="square">
+            <a:spAutoFit/>
+          </a:bodyPr>
+          <a:lstStyle/>
+          <a:p>
+            <a:pPr algn="l">
+              <a:defRPr sz="1000" b="1">
+                <a:solidFill>
+                  <a:srgbClr val="FFFFFF"/>
+                </a:solidFill>
+              </a:defRPr>
+            </a:pPr>
+            <a:r>
+              <a:t>4+ occupants on motorcycle.</a:t>
+            </a:r>
+          </a:p>
+        </p:txBody>
+      </p:sp>
+      <p:sp>
+        <p:nvSpPr>
           <p:cNvPr id="12" name="TextBox 11"/>
           <p:cNvSpPr txBox="1"/>
           <p:nvPr/>
         </p:nvSpPr>
         <p:spPr>
           <a:xfrm>
-            <a:off x="7863840" y="2148840"/>
+            <a:off x="7863840" y="2651760"/>
             <a:ext cx="3291840" cy="274320"/>
           </a:xfrm>
           <a:prstGeom prst="rect">
@@ -7978,14 +7845,14 @@
           <a:lstStyle/>
           <a:p>
             <a:pPr algn="l">
-              <a:defRPr sz="1000" b="1">
-                <a:solidFill>
-                  <a:srgbClr val="FFFFFF"/>
-                </a:solidFill>
-              </a:defRPr>
-            </a:pPr>
-            <a:r>
-              <a:t>4+ occupants on motorcycle.</a:t>
+              <a:defRPr sz="1000" b="0">
+                <a:solidFill>
+                  <a:srgbClr val="9CA3AF"/>
+                </a:solidFill>
+              </a:defRPr>
+            </a:pPr>
+            <a:r>
+              <a:t>Confidence: 95% | Risk: 95</a:t>
             </a:r>
           </a:p>
         </p:txBody>
@@ -7993,41 +7860,6 @@
       <p:sp>
         <p:nvSpPr>
           <p:cNvPr id="13" name="TextBox 12"/>
-          <p:cNvSpPr txBox="1"/>
-          <p:nvPr/>
-        </p:nvSpPr>
-        <p:spPr>
-          <a:xfrm>
-            <a:off x="7863840" y="2468880"/>
-            <a:ext cx="3291840" cy="274320"/>
-          </a:xfrm>
-          <a:prstGeom prst="rect">
-            <a:avLst/>
-          </a:prstGeom>
-          <a:noFill/>
-        </p:spPr>
-        <p:txBody>
-          <a:bodyPr wrap="square">
-            <a:spAutoFit/>
-          </a:bodyPr>
-          <a:lstStyle/>
-          <a:p>
-            <a:pPr algn="l">
-              <a:defRPr sz="1000" b="0">
-                <a:solidFill>
-                  <a:srgbClr val="9CA3AF"/>
-                </a:solidFill>
-              </a:defRPr>
-            </a:pPr>
-            <a:r>
-              <a:t>Confidence: 95% | Risk: 95</a:t>
-            </a:r>
-          </a:p>
-        </p:txBody>
-      </p:sp>
-      <p:sp>
-        <p:nvSpPr>
-          <p:cNvPr id="14" name="TextBox 13"/>
           <p:cNvSpPr txBox="1"/>
           <p:nvPr/>
         </p:nvSpPr>
@@ -8062,7 +7894,7 @@
       </p:sp>
       <p:sp>
         <p:nvSpPr>
-          <p:cNvPr id="15" name="TextBox 14"/>
+          <p:cNvPr id="14" name="TextBox 13"/>
           <p:cNvSpPr txBox="1"/>
           <p:nvPr/>
         </p:nvSpPr>
@@ -8097,7 +7929,7 @@
       </p:sp>
       <p:sp>
         <p:nvSpPr>
-          <p:cNvPr id="16" name="TextBox 15"/>
+          <p:cNvPr id="15" name="TextBox 14"/>
           <p:cNvSpPr txBox="1"/>
           <p:nvPr/>
         </p:nvSpPr>
@@ -8132,7 +7964,7 @@
       </p:sp>
       <p:sp>
         <p:nvSpPr>
-          <p:cNvPr id="17" name="TextBox 16"/>
+          <p:cNvPr id="16" name="TextBox 15"/>
           <p:cNvSpPr txBox="1"/>
           <p:nvPr/>
         </p:nvSpPr>
@@ -8167,7 +7999,7 @@
       </p:sp>
       <p:sp>
         <p:nvSpPr>
-          <p:cNvPr id="18" name="TextBox 17"/>
+          <p:cNvPr id="17" name="TextBox 16"/>
           <p:cNvSpPr txBox="1"/>
           <p:nvPr/>
         </p:nvSpPr>
@@ -8320,22 +8152,22 @@
         </p:nvSpPr>
         <p:spPr>
           <a:xfrm>
-            <a:off x="914400" y="1097280"/>
-            <a:ext cx="10058400" cy="731520"/>
-          </a:xfrm>
-          <a:prstGeom prst="rect">
-            <a:avLst/>
-          </a:prstGeom>
-          <a:noFill/>
-        </p:spPr>
-        <p:txBody>
-          <a:bodyPr wrap="square">
-            <a:spAutoFit/>
-          </a:bodyPr>
-          <a:lstStyle/>
-          <a:p>
-            <a:pPr algn="l">
-              <a:defRPr sz="3600" b="1">
+            <a:off x="914400" y="914400"/>
+            <a:ext cx="10058400" cy="594360"/>
+          </a:xfrm>
+          <a:prstGeom prst="rect">
+            <a:avLst/>
+          </a:prstGeom>
+          <a:noFill/>
+        </p:spPr>
+        <p:txBody>
+          <a:bodyPr wrap="square">
+            <a:spAutoFit/>
+          </a:bodyPr>
+          <a:lstStyle/>
+          <a:p>
+            <a:pPr algn="l">
+              <a:defRPr sz="3200" b="1">
                 <a:solidFill>
                   <a:srgbClr val="FFFFFF"/>
                 </a:solidFill>
@@ -8355,22 +8187,22 @@
         </p:nvSpPr>
         <p:spPr>
           <a:xfrm>
-            <a:off x="914400" y="1828800"/>
-            <a:ext cx="10058400" cy="457200"/>
-          </a:xfrm>
-          <a:prstGeom prst="rect">
-            <a:avLst/>
-          </a:prstGeom>
-          <a:noFill/>
-        </p:spPr>
-        <p:txBody>
-          <a:bodyPr wrap="square">
-            <a:spAutoFit/>
-          </a:bodyPr>
-          <a:lstStyle/>
-          <a:p>
-            <a:pPr algn="l">
-              <a:defRPr sz="1800" b="0">
+            <a:off x="914400" y="1600200"/>
+            <a:ext cx="10058400" cy="274320"/>
+          </a:xfrm>
+          <a:prstGeom prst="rect">
+            <a:avLst/>
+          </a:prstGeom>
+          <a:noFill/>
+        </p:spPr>
+        <p:txBody>
+          <a:bodyPr wrap="square">
+            <a:spAutoFit/>
+          </a:bodyPr>
+          <a:lstStyle/>
+          <a:p>
+            <a:pPr algn="l">
+              <a:defRPr sz="1400" b="0">
                 <a:solidFill>
                   <a:srgbClr val="9CA3AF"/>
                 </a:solidFill>
@@ -8382,89 +8214,33 @@
           </a:p>
         </p:txBody>
       </p:sp>
-      <p:sp>
-        <p:nvSpPr>
-          <p:cNvPr id="6" name="Rounded Rectangle 5"/>
-          <p:cNvSpPr/>
-          <p:nvPr/>
-        </p:nvSpPr>
-        <p:spPr>
-          <a:xfrm>
-            <a:off x="457200" y="2011680"/>
-            <a:ext cx="5303520" cy="4114800"/>
-          </a:xfrm>
-          <a:prstGeom prst="roundRect">
-            <a:avLst/>
-          </a:prstGeom>
-          <a:solidFill>
-            <a:srgbClr val="1A2040"/>
-          </a:solidFill>
-          <a:ln w="12700">
-            <a:solidFill>
-              <a:srgbClr val="9CA3AF"/>
-            </a:solidFill>
-          </a:ln>
-        </p:spPr>
-        <p:style>
-          <a:lnRef idx="1">
-            <a:schemeClr val="accent1"/>
-          </a:lnRef>
-          <a:fillRef idx="3">
-            <a:schemeClr val="accent1"/>
-          </a:fillRef>
-          <a:effectRef idx="2">
-            <a:schemeClr val="accent1"/>
-          </a:effectRef>
-          <a:fontRef idx="minor">
-            <a:schemeClr val="lt1"/>
-          </a:fontRef>
-        </p:style>
-        <p:txBody>
-          <a:bodyPr rtlCol="0" anchor="ctr"/>
-          <a:lstStyle/>
-          <a:p>
-            <a:pPr algn="ctr"/>
-          </a:p>
-        </p:txBody>
-      </p:sp>
-      <p:sp>
-        <p:nvSpPr>
-          <p:cNvPr id="7" name="TextBox 6"/>
-          <p:cNvSpPr txBox="1"/>
-          <p:nvPr/>
-        </p:nvSpPr>
-        <p:spPr>
-          <a:xfrm>
-            <a:off x="457200" y="3200400"/>
-            <a:ext cx="5303520" cy="914400"/>
-          </a:xfrm>
-          <a:prstGeom prst="rect">
-            <a:avLst/>
-          </a:prstGeom>
-          <a:noFill/>
-        </p:spPr>
-        <p:txBody>
-          <a:bodyPr wrap="square">
-            <a:spAutoFit/>
-          </a:bodyPr>
-          <a:lstStyle/>
-          <a:p>
-            <a:pPr algn="ctr">
-              <a:defRPr sz="1600" b="0">
-                <a:solidFill>
-                  <a:srgbClr val="9CA3AF"/>
-                </a:solidFill>
-              </a:defRPr>
-            </a:pPr>
-            <a:r>
-              <a:t>[ Source Image ]</a:t>
-            </a:r>
-          </a:p>
-        </p:txBody>
-      </p:sp>
-      <p:sp>
-        <p:nvSpPr>
-          <p:cNvPr id="8" name="Rounded Rectangle 7"/>
+      <p:pic>
+        <p:nvPicPr>
+          <p:cNvPr id="6" name="Picture 5" descr="26d7fe5f9e5d4793954d113e5a3047e6_HELMET_MISSING_002.png"/>
+          <p:cNvPicPr>
+            <a:picLocks noChangeAspect="1"/>
+          </p:cNvPicPr>
+          <p:nvPr/>
+        </p:nvPicPr>
+        <p:blipFill>
+          <a:blip r:embed="rId2"/>
+          <a:stretch>
+            <a:fillRect/>
+          </a:stretch>
+        </p:blipFill>
+        <p:spPr>
+          <a:xfrm>
+            <a:off x="457200" y="2194560"/>
+            <a:ext cx="5303520" cy="4023360"/>
+          </a:xfrm>
+          <a:prstGeom prst="rect">
+            <a:avLst/>
+          </a:prstGeom>
+        </p:spPr>
+      </p:pic>
+      <p:sp>
+        <p:nvSpPr>
+          <p:cNvPr id="7" name="Rounded Rectangle 6"/>
           <p:cNvSpPr/>
           <p:nvPr/>
         </p:nvSpPr>
@@ -8518,22 +8294,22 @@
       </p:sp>
       <p:pic>
         <p:nvPicPr>
-          <p:cNvPr id="9" name="Picture 8" descr="HELMET_MISSING_002_evidence_20260621_114143_832551.jpg"/>
+          <p:cNvPr id="8" name="Picture 7" descr="HELMET_MISSING_002_evidence_20260620_230304_000133.jpg"/>
           <p:cNvPicPr>
             <a:picLocks noChangeAspect="1"/>
           </p:cNvPicPr>
           <p:nvPr/>
         </p:nvPicPr>
         <p:blipFill>
-          <a:blip r:embed="rId2"/>
+          <a:blip r:embed="rId3"/>
           <a:stretch>
             <a:fillRect/>
           </a:stretch>
         </p:blipFill>
         <p:spPr>
           <a:xfrm>
-            <a:off x="6217920" y="2011680"/>
-            <a:ext cx="5303520" cy="4114800"/>
+            <a:off x="6217920" y="2194560"/>
+            <a:ext cx="5303520" cy="4023360"/>
           </a:xfrm>
           <a:prstGeom prst="rect">
             <a:avLst/>
@@ -8542,7 +8318,7 @@
       </p:pic>
       <p:sp>
         <p:nvSpPr>
-          <p:cNvPr id="10" name="Rounded Rectangle 9"/>
+          <p:cNvPr id="9" name="Rounded Rectangle 8"/>
           <p:cNvSpPr/>
           <p:nvPr/>
         </p:nvSpPr>
@@ -8596,13 +8372,13 @@
       </p:sp>
       <p:sp>
         <p:nvSpPr>
-          <p:cNvPr id="11" name="Rounded Rectangle 10"/>
+          <p:cNvPr id="10" name="Rounded Rectangle 9"/>
           <p:cNvSpPr/>
           <p:nvPr/>
         </p:nvSpPr>
         <p:spPr>
           <a:xfrm>
-            <a:off x="7772400" y="2103120"/>
+            <a:off x="7772400" y="2286000"/>
             <a:ext cx="3474720" cy="1280160"/>
           </a:xfrm>
           <a:prstGeom prst="roundRect">
@@ -8641,13 +8417,48 @@
       </p:sp>
       <p:sp>
         <p:nvSpPr>
+          <p:cNvPr id="11" name="TextBox 10"/>
+          <p:cNvSpPr txBox="1"/>
+          <p:nvPr/>
+        </p:nvSpPr>
+        <p:spPr>
+          <a:xfrm>
+            <a:off x="7863840" y="2331720"/>
+            <a:ext cx="3291840" cy="274320"/>
+          </a:xfrm>
+          <a:prstGeom prst="rect">
+            <a:avLst/>
+          </a:prstGeom>
+          <a:noFill/>
+        </p:spPr>
+        <p:txBody>
+          <a:bodyPr wrap="square">
+            <a:spAutoFit/>
+          </a:bodyPr>
+          <a:lstStyle/>
+          <a:p>
+            <a:pPr algn="l">
+              <a:defRPr sz="1000" b="1">
+                <a:solidFill>
+                  <a:srgbClr val="FFFFFF"/>
+                </a:solidFill>
+              </a:defRPr>
+            </a:pPr>
+            <a:r>
+              <a:t>Vehicle on wrong road side.</a:t>
+            </a:r>
+          </a:p>
+        </p:txBody>
+      </p:sp>
+      <p:sp>
+        <p:nvSpPr>
           <p:cNvPr id="12" name="TextBox 11"/>
           <p:cNvSpPr txBox="1"/>
           <p:nvPr/>
         </p:nvSpPr>
         <p:spPr>
           <a:xfrm>
-            <a:off x="7863840" y="2148840"/>
+            <a:off x="7863840" y="2651760"/>
             <a:ext cx="3291840" cy="274320"/>
           </a:xfrm>
           <a:prstGeom prst="rect">
@@ -8662,14 +8473,14 @@
           <a:lstStyle/>
           <a:p>
             <a:pPr algn="l">
-              <a:defRPr sz="1000" b="1">
-                <a:solidFill>
-                  <a:srgbClr val="FFFFFF"/>
-                </a:solidFill>
-              </a:defRPr>
-            </a:pPr>
-            <a:r>
-              <a:t>Vehicle on wrong road side.</a:t>
+              <a:defRPr sz="1000" b="0">
+                <a:solidFill>
+                  <a:srgbClr val="9CA3AF"/>
+                </a:solidFill>
+              </a:defRPr>
+            </a:pPr>
+            <a:r>
+              <a:t>Confidence: 85% | Risk: 85</a:t>
             </a:r>
           </a:p>
         </p:txBody>
@@ -8677,41 +8488,6 @@
       <p:sp>
         <p:nvSpPr>
           <p:cNvPr id="13" name="TextBox 12"/>
-          <p:cNvSpPr txBox="1"/>
-          <p:nvPr/>
-        </p:nvSpPr>
-        <p:spPr>
-          <a:xfrm>
-            <a:off x="7863840" y="2468880"/>
-            <a:ext cx="3291840" cy="274320"/>
-          </a:xfrm>
-          <a:prstGeom prst="rect">
-            <a:avLst/>
-          </a:prstGeom>
-          <a:noFill/>
-        </p:spPr>
-        <p:txBody>
-          <a:bodyPr wrap="square">
-            <a:spAutoFit/>
-          </a:bodyPr>
-          <a:lstStyle/>
-          <a:p>
-            <a:pPr algn="l">
-              <a:defRPr sz="1000" b="0">
-                <a:solidFill>
-                  <a:srgbClr val="9CA3AF"/>
-                </a:solidFill>
-              </a:defRPr>
-            </a:pPr>
-            <a:r>
-              <a:t>Confidence: 85% | Risk: 85</a:t>
-            </a:r>
-          </a:p>
-        </p:txBody>
-      </p:sp>
-      <p:sp>
-        <p:nvSpPr>
-          <p:cNvPr id="14" name="TextBox 13"/>
           <p:cNvSpPr txBox="1"/>
           <p:nvPr/>
         </p:nvSpPr>
@@ -8746,7 +8522,7 @@
       </p:sp>
       <p:sp>
         <p:nvSpPr>
-          <p:cNvPr id="15" name="TextBox 14"/>
+          <p:cNvPr id="14" name="TextBox 13"/>
           <p:cNvSpPr txBox="1"/>
           <p:nvPr/>
         </p:nvSpPr>
@@ -8781,7 +8557,7 @@
       </p:sp>
       <p:sp>
         <p:nvSpPr>
-          <p:cNvPr id="16" name="TextBox 15"/>
+          <p:cNvPr id="15" name="TextBox 14"/>
           <p:cNvSpPr txBox="1"/>
           <p:nvPr/>
         </p:nvSpPr>
@@ -8816,7 +8592,7 @@
       </p:sp>
       <p:sp>
         <p:nvSpPr>
-          <p:cNvPr id="17" name="TextBox 16"/>
+          <p:cNvPr id="16" name="TextBox 15"/>
           <p:cNvSpPr txBox="1"/>
           <p:nvPr/>
         </p:nvSpPr>
@@ -8851,7 +8627,7 @@
       </p:sp>
       <p:sp>
         <p:nvSpPr>
-          <p:cNvPr id="18" name="TextBox 17"/>
+          <p:cNvPr id="17" name="TextBox 16"/>
           <p:cNvSpPr txBox="1"/>
           <p:nvPr/>
         </p:nvSpPr>
@@ -9004,22 +8780,22 @@
         </p:nvSpPr>
         <p:spPr>
           <a:xfrm>
-            <a:off x="914400" y="1097280"/>
-            <a:ext cx="10058400" cy="731520"/>
-          </a:xfrm>
-          <a:prstGeom prst="rect">
-            <a:avLst/>
-          </a:prstGeom>
-          <a:noFill/>
-        </p:spPr>
-        <p:txBody>
-          <a:bodyPr wrap="square">
-            <a:spAutoFit/>
-          </a:bodyPr>
-          <a:lstStyle/>
-          <a:p>
-            <a:pPr algn="l">
-              <a:defRPr sz="3600" b="1">
+            <a:off x="914400" y="914400"/>
+            <a:ext cx="10058400" cy="594360"/>
+          </a:xfrm>
+          <a:prstGeom prst="rect">
+            <a:avLst/>
+          </a:prstGeom>
+          <a:noFill/>
+        </p:spPr>
+        <p:txBody>
+          <a:bodyPr wrap="square">
+            <a:spAutoFit/>
+          </a:bodyPr>
+          <a:lstStyle/>
+          <a:p>
+            <a:pPr algn="l">
+              <a:defRPr sz="3200" b="1">
                 <a:solidFill>
                   <a:srgbClr val="FFFFFF"/>
                 </a:solidFill>
@@ -9039,22 +8815,22 @@
         </p:nvSpPr>
         <p:spPr>
           <a:xfrm>
-            <a:off x="914400" y="1828800"/>
-            <a:ext cx="10058400" cy="457200"/>
-          </a:xfrm>
-          <a:prstGeom prst="rect">
-            <a:avLst/>
-          </a:prstGeom>
-          <a:noFill/>
-        </p:spPr>
-        <p:txBody>
-          <a:bodyPr wrap="square">
-            <a:spAutoFit/>
-          </a:bodyPr>
-          <a:lstStyle/>
-          <a:p>
-            <a:pPr algn="l">
-              <a:defRPr sz="1800" b="0">
+            <a:off x="914400" y="1600200"/>
+            <a:ext cx="10058400" cy="274320"/>
+          </a:xfrm>
+          <a:prstGeom prst="rect">
+            <a:avLst/>
+          </a:prstGeom>
+          <a:noFill/>
+        </p:spPr>
+        <p:txBody>
+          <a:bodyPr wrap="square">
+            <a:spAutoFit/>
+          </a:bodyPr>
+          <a:lstStyle/>
+          <a:p>
+            <a:pPr algn="l">
+              <a:defRPr sz="1400" b="0">
                 <a:solidFill>
                   <a:srgbClr val="9CA3AF"/>
                 </a:solidFill>
@@ -9931,22 +9707,22 @@
         </p:nvSpPr>
         <p:spPr>
           <a:xfrm>
-            <a:off x="914400" y="1097280"/>
-            <a:ext cx="10058400" cy="731520"/>
-          </a:xfrm>
-          <a:prstGeom prst="rect">
-            <a:avLst/>
-          </a:prstGeom>
-          <a:noFill/>
-        </p:spPr>
-        <p:txBody>
-          <a:bodyPr wrap="square">
-            <a:spAutoFit/>
-          </a:bodyPr>
-          <a:lstStyle/>
-          <a:p>
-            <a:pPr algn="l">
-              <a:defRPr sz="3600" b="1">
+            <a:off x="914400" y="914400"/>
+            <a:ext cx="10058400" cy="594360"/>
+          </a:xfrm>
+          <a:prstGeom prst="rect">
+            <a:avLst/>
+          </a:prstGeom>
+          <a:noFill/>
+        </p:spPr>
+        <p:txBody>
+          <a:bodyPr wrap="square">
+            <a:spAutoFit/>
+          </a:bodyPr>
+          <a:lstStyle/>
+          <a:p>
+            <a:pPr algn="l">
+              <a:defRPr sz="3200" b="1">
                 <a:solidFill>
                   <a:srgbClr val="FFFFFF"/>
                 </a:solidFill>
@@ -9966,7 +9742,7 @@
         </p:nvSpPr>
         <p:spPr>
           <a:xfrm>
-            <a:off x="548640" y="2011680"/>
+            <a:off x="548640" y="2286000"/>
             <a:ext cx="5394960" cy="1920240"/>
           </a:xfrm>
           <a:prstGeom prst="roundRect">
@@ -10011,7 +9787,7 @@
         </p:nvSpPr>
         <p:spPr>
           <a:xfrm>
-            <a:off x="640080" y="2103120"/>
+            <a:off x="640080" y="2377440"/>
             <a:ext cx="5212080" cy="365760"/>
           </a:xfrm>
           <a:prstGeom prst="roundRect">
@@ -10056,7 +9832,7 @@
         </p:nvSpPr>
         <p:spPr>
           <a:xfrm>
-            <a:off x="685800" y="2148840"/>
+            <a:off x="685800" y="2423160"/>
             <a:ext cx="5120640" cy="274320"/>
           </a:xfrm>
           <a:prstGeom prst="rect">
@@ -10091,7 +9867,7 @@
         </p:nvSpPr>
         <p:spPr>
           <a:xfrm>
-            <a:off x="685800" y="2560320"/>
+            <a:off x="685800" y="2834640"/>
             <a:ext cx="5120640" cy="1280160"/>
           </a:xfrm>
           <a:prstGeom prst="rect">
@@ -10134,7 +9910,7 @@
         </p:nvSpPr>
         <p:spPr>
           <a:xfrm>
-            <a:off x="6309360" y="2011680"/>
+            <a:off x="6309360" y="2286000"/>
             <a:ext cx="5394960" cy="1920240"/>
           </a:xfrm>
           <a:prstGeom prst="roundRect">
@@ -10179,7 +9955,7 @@
         </p:nvSpPr>
         <p:spPr>
           <a:xfrm>
-            <a:off x="6400800" y="2103120"/>
+            <a:off x="6400800" y="2377440"/>
             <a:ext cx="5212080" cy="365760"/>
           </a:xfrm>
           <a:prstGeom prst="roundRect">
@@ -10224,7 +10000,7 @@
         </p:nvSpPr>
         <p:spPr>
           <a:xfrm>
-            <a:off x="6446520" y="2148840"/>
+            <a:off x="6446520" y="2423160"/>
             <a:ext cx="5120640" cy="274320"/>
           </a:xfrm>
           <a:prstGeom prst="rect">
@@ -10259,7 +10035,7 @@
         </p:nvSpPr>
         <p:spPr>
           <a:xfrm>
-            <a:off x="6446520" y="2560320"/>
+            <a:off x="6446520" y="2834640"/>
             <a:ext cx="5120640" cy="1280160"/>
           </a:xfrm>
           <a:prstGeom prst="rect">
@@ -10302,7 +10078,7 @@
         </p:nvSpPr>
         <p:spPr>
           <a:xfrm>
-            <a:off x="548640" y="4206240"/>
+            <a:off x="548640" y="4480560"/>
             <a:ext cx="5394960" cy="1920240"/>
           </a:xfrm>
           <a:prstGeom prst="roundRect">
@@ -10347,7 +10123,7 @@
         </p:nvSpPr>
         <p:spPr>
           <a:xfrm>
-            <a:off x="640080" y="4297680"/>
+            <a:off x="640080" y="4572000"/>
             <a:ext cx="5212080" cy="365760"/>
           </a:xfrm>
           <a:prstGeom prst="roundRect">
@@ -10392,7 +10168,7 @@
         </p:nvSpPr>
         <p:spPr>
           <a:xfrm>
-            <a:off x="685800" y="4343400"/>
+            <a:off x="685800" y="4617720"/>
             <a:ext cx="5120640" cy="274320"/>
           </a:xfrm>
           <a:prstGeom prst="rect">
@@ -10427,7 +10203,7 @@
         </p:nvSpPr>
         <p:spPr>
           <a:xfrm>
-            <a:off x="685800" y="4754880"/>
+            <a:off x="685800" y="5029200"/>
             <a:ext cx="5120640" cy="1280160"/>
           </a:xfrm>
           <a:prstGeom prst="rect">
@@ -10470,7 +10246,7 @@
         </p:nvSpPr>
         <p:spPr>
           <a:xfrm>
-            <a:off x="6309360" y="4206240"/>
+            <a:off x="6309360" y="4480560"/>
             <a:ext cx="5394960" cy="1920240"/>
           </a:xfrm>
           <a:prstGeom prst="roundRect">
@@ -10515,7 +10291,7 @@
         </p:nvSpPr>
         <p:spPr>
           <a:xfrm>
-            <a:off x="6400800" y="4297680"/>
+            <a:off x="6400800" y="4572000"/>
             <a:ext cx="5212080" cy="365760"/>
           </a:xfrm>
           <a:prstGeom prst="roundRect">
@@ -10560,7 +10336,7 @@
         </p:nvSpPr>
         <p:spPr>
           <a:xfrm>
-            <a:off x="6446520" y="4343400"/>
+            <a:off x="6446520" y="4617720"/>
             <a:ext cx="5120640" cy="274320"/>
           </a:xfrm>
           <a:prstGeom prst="rect">
@@ -10595,7 +10371,7 @@
         </p:nvSpPr>
         <p:spPr>
           <a:xfrm>
-            <a:off x="6446520" y="4754880"/>
+            <a:off x="6446520" y="5029200"/>
             <a:ext cx="5120640" cy="1280160"/>
           </a:xfrm>
           <a:prstGeom prst="rect">
@@ -10750,22 +10526,22 @@
         </p:nvSpPr>
         <p:spPr>
           <a:xfrm>
-            <a:off x="914400" y="1097280"/>
-            <a:ext cx="10058400" cy="731520"/>
-          </a:xfrm>
-          <a:prstGeom prst="rect">
-            <a:avLst/>
-          </a:prstGeom>
-          <a:noFill/>
-        </p:spPr>
-        <p:txBody>
-          <a:bodyPr wrap="square">
-            <a:spAutoFit/>
-          </a:bodyPr>
-          <a:lstStyle/>
-          <a:p>
-            <a:pPr algn="l">
-              <a:defRPr sz="3600" b="1">
+            <a:off x="914400" y="914400"/>
+            <a:ext cx="10058400" cy="594360"/>
+          </a:xfrm>
+          <a:prstGeom prst="rect">
+            <a:avLst/>
+          </a:prstGeom>
+          <a:noFill/>
+        </p:spPr>
+        <p:txBody>
+          <a:bodyPr wrap="square">
+            <a:spAutoFit/>
+          </a:bodyPr>
+          <a:lstStyle/>
+          <a:p>
+            <a:pPr algn="l">
+              <a:defRPr sz="3200" b="1">
                 <a:solidFill>
                   <a:srgbClr val="FFFFFF"/>
                 </a:solidFill>
@@ -10785,22 +10561,22 @@
         </p:nvSpPr>
         <p:spPr>
           <a:xfrm>
-            <a:off x="914400" y="1828800"/>
-            <a:ext cx="10058400" cy="457200"/>
-          </a:xfrm>
-          <a:prstGeom prst="rect">
-            <a:avLst/>
-          </a:prstGeom>
-          <a:noFill/>
-        </p:spPr>
-        <p:txBody>
-          <a:bodyPr wrap="square">
-            <a:spAutoFit/>
-          </a:bodyPr>
-          <a:lstStyle/>
-          <a:p>
-            <a:pPr algn="l">
-              <a:defRPr sz="1800" b="0">
+            <a:off x="914400" y="1600200"/>
+            <a:ext cx="10058400" cy="274320"/>
+          </a:xfrm>
+          <a:prstGeom prst="rect">
+            <a:avLst/>
+          </a:prstGeom>
+          <a:noFill/>
+        </p:spPr>
+        <p:txBody>
+          <a:bodyPr wrap="square">
+            <a:spAutoFit/>
+          </a:bodyPr>
+          <a:lstStyle/>
+          <a:p>
+            <a:pPr algn="l">
+              <a:defRPr sz="1400" b="0">
                 <a:solidFill>
                   <a:srgbClr val="9CA3AF"/>
                 </a:solidFill>
@@ -10820,7 +10596,7 @@
         </p:nvSpPr>
         <p:spPr>
           <a:xfrm>
-            <a:off x="731520" y="2011680"/>
+            <a:off x="731520" y="2286000"/>
             <a:ext cx="5303520" cy="914400"/>
           </a:xfrm>
           <a:prstGeom prst="roundRect">
@@ -10865,7 +10641,7 @@
         </p:nvSpPr>
         <p:spPr>
           <a:xfrm>
-            <a:off x="914400" y="2057400"/>
+            <a:off x="914400" y="2331720"/>
             <a:ext cx="4937760" cy="274320"/>
           </a:xfrm>
           <a:prstGeom prst="rect">
@@ -10900,7 +10676,7 @@
         </p:nvSpPr>
         <p:spPr>
           <a:xfrm>
-            <a:off x="914400" y="2331720"/>
+            <a:off x="914400" y="2606040"/>
             <a:ext cx="4937760" cy="228600"/>
           </a:xfrm>
           <a:prstGeom prst="rect">
@@ -10935,7 +10711,7 @@
         </p:nvSpPr>
         <p:spPr>
           <a:xfrm>
-            <a:off x="914400" y="2560320"/>
+            <a:off x="914400" y="2834640"/>
             <a:ext cx="4937760" cy="274320"/>
           </a:xfrm>
           <a:prstGeom prst="rect">
@@ -10970,7 +10746,7 @@
         </p:nvSpPr>
         <p:spPr>
           <a:xfrm>
-            <a:off x="6400800" y="2194560"/>
+            <a:off x="6400800" y="2468880"/>
             <a:ext cx="2286000" cy="365760"/>
           </a:xfrm>
           <a:prstGeom prst="roundRect">
@@ -11015,7 +10791,7 @@
         </p:nvSpPr>
         <p:spPr>
           <a:xfrm>
-            <a:off x="6400800" y="2240280"/>
+            <a:off x="6400800" y="2514600"/>
             <a:ext cx="2286000" cy="274320"/>
           </a:xfrm>
           <a:prstGeom prst="rect">
@@ -11050,7 +10826,7 @@
         </p:nvSpPr>
         <p:spPr>
           <a:xfrm>
-            <a:off x="7498079" y="2880360"/>
+            <a:off x="7498079" y="3154680"/>
             <a:ext cx="274320" cy="182880"/>
           </a:xfrm>
           <a:prstGeom prst="downArrow">
@@ -11093,7 +10869,7 @@
         </p:nvSpPr>
         <p:spPr>
           <a:xfrm>
-            <a:off x="731520" y="3108960"/>
+            <a:off x="731520" y="3383280"/>
             <a:ext cx="5303520" cy="914400"/>
           </a:xfrm>
           <a:prstGeom prst="roundRect">
@@ -11138,7 +10914,7 @@
         </p:nvSpPr>
         <p:spPr>
           <a:xfrm>
-            <a:off x="914400" y="3154680"/>
+            <a:off x="914400" y="3429000"/>
             <a:ext cx="4937760" cy="274320"/>
           </a:xfrm>
           <a:prstGeom prst="rect">
@@ -11173,7 +10949,7 @@
         </p:nvSpPr>
         <p:spPr>
           <a:xfrm>
-            <a:off x="914400" y="3429000"/>
+            <a:off x="914400" y="3703320"/>
             <a:ext cx="4937760" cy="228600"/>
           </a:xfrm>
           <a:prstGeom prst="rect">
@@ -11208,7 +10984,7 @@
         </p:nvSpPr>
         <p:spPr>
           <a:xfrm>
-            <a:off x="914400" y="3657600"/>
+            <a:off x="914400" y="3931920"/>
             <a:ext cx="4937760" cy="274320"/>
           </a:xfrm>
           <a:prstGeom prst="rect">
@@ -11243,7 +11019,7 @@
         </p:nvSpPr>
         <p:spPr>
           <a:xfrm>
-            <a:off x="6400800" y="3291840"/>
+            <a:off x="6400800" y="3566160"/>
             <a:ext cx="2286000" cy="365760"/>
           </a:xfrm>
           <a:prstGeom prst="roundRect">
@@ -11288,7 +11064,7 @@
         </p:nvSpPr>
         <p:spPr>
           <a:xfrm>
-            <a:off x="6400800" y="3337560"/>
+            <a:off x="6400800" y="3611880"/>
             <a:ext cx="2286000" cy="274320"/>
           </a:xfrm>
           <a:prstGeom prst="rect">
@@ -11323,7 +11099,7 @@
         </p:nvSpPr>
         <p:spPr>
           <a:xfrm>
-            <a:off x="7498079" y="3977640"/>
+            <a:off x="7498079" y="4251960"/>
             <a:ext cx="274320" cy="182880"/>
           </a:xfrm>
           <a:prstGeom prst="downArrow">
@@ -11366,7 +11142,7 @@
         </p:nvSpPr>
         <p:spPr>
           <a:xfrm>
-            <a:off x="731520" y="4206240"/>
+            <a:off x="731520" y="4480560"/>
             <a:ext cx="5303520" cy="914400"/>
           </a:xfrm>
           <a:prstGeom prst="roundRect">
@@ -11411,7 +11187,7 @@
         </p:nvSpPr>
         <p:spPr>
           <a:xfrm>
-            <a:off x="914400" y="4251960"/>
+            <a:off x="914400" y="4526280"/>
             <a:ext cx="4937760" cy="274320"/>
           </a:xfrm>
           <a:prstGeom prst="rect">
@@ -11446,7 +11222,7 @@
         </p:nvSpPr>
         <p:spPr>
           <a:xfrm>
-            <a:off x="914400" y="4526280"/>
+            <a:off x="914400" y="4800600"/>
             <a:ext cx="4937760" cy="228600"/>
           </a:xfrm>
           <a:prstGeom prst="rect">
@@ -11481,7 +11257,7 @@
         </p:nvSpPr>
         <p:spPr>
           <a:xfrm>
-            <a:off x="914400" y="4754880"/>
+            <a:off x="914400" y="5029200"/>
             <a:ext cx="4937760" cy="274320"/>
           </a:xfrm>
           <a:prstGeom prst="rect">
@@ -11516,7 +11292,7 @@
         </p:nvSpPr>
         <p:spPr>
           <a:xfrm>
-            <a:off x="6400800" y="4389120"/>
+            <a:off x="6400800" y="4663440"/>
             <a:ext cx="2286000" cy="365760"/>
           </a:xfrm>
           <a:prstGeom prst="roundRect">
@@ -11561,7 +11337,7 @@
         </p:nvSpPr>
         <p:spPr>
           <a:xfrm>
-            <a:off x="6400800" y="4434840"/>
+            <a:off x="6400800" y="4709160"/>
             <a:ext cx="2286000" cy="274320"/>
           </a:xfrm>
           <a:prstGeom prst="rect">
@@ -11596,7 +11372,7 @@
         </p:nvSpPr>
         <p:spPr>
           <a:xfrm>
-            <a:off x="7498079" y="5074920"/>
+            <a:off x="7498079" y="5349240"/>
             <a:ext cx="274320" cy="182880"/>
           </a:xfrm>
           <a:prstGeom prst="downArrow">
@@ -11639,7 +11415,7 @@
         </p:nvSpPr>
         <p:spPr>
           <a:xfrm>
-            <a:off x="731520" y="5303520"/>
+            <a:off x="731520" y="5577840"/>
             <a:ext cx="5303520" cy="914400"/>
           </a:xfrm>
           <a:prstGeom prst="roundRect">
@@ -11684,7 +11460,7 @@
         </p:nvSpPr>
         <p:spPr>
           <a:xfrm>
-            <a:off x="914400" y="5349240"/>
+            <a:off x="914400" y="5623560"/>
             <a:ext cx="4937760" cy="274320"/>
           </a:xfrm>
           <a:prstGeom prst="rect">
@@ -11719,7 +11495,7 @@
         </p:nvSpPr>
         <p:spPr>
           <a:xfrm>
-            <a:off x="914400" y="5623560"/>
+            <a:off x="914400" y="5897880"/>
             <a:ext cx="4937760" cy="228600"/>
           </a:xfrm>
           <a:prstGeom prst="rect">
@@ -11754,7 +11530,7 @@
         </p:nvSpPr>
         <p:spPr>
           <a:xfrm>
-            <a:off x="914400" y="5852160"/>
+            <a:off x="914400" y="6126480"/>
             <a:ext cx="4937760" cy="274320"/>
           </a:xfrm>
           <a:prstGeom prst="rect">
@@ -11789,7 +11565,7 @@
         </p:nvSpPr>
         <p:spPr>
           <a:xfrm>
-            <a:off x="6400800" y="5486400"/>
+            <a:off x="6400800" y="5760720"/>
             <a:ext cx="2286000" cy="365760"/>
           </a:xfrm>
           <a:prstGeom prst="roundRect">
@@ -11834,7 +11610,7 @@
         </p:nvSpPr>
         <p:spPr>
           <a:xfrm>
-            <a:off x="6400800" y="5532120"/>
+            <a:off x="6400800" y="5806440"/>
             <a:ext cx="2286000" cy="274320"/>
           </a:xfrm>
           <a:prstGeom prst="rect">
@@ -11981,22 +11757,22 @@
         </p:nvSpPr>
         <p:spPr>
           <a:xfrm>
-            <a:off x="914400" y="1097280"/>
-            <a:ext cx="10058400" cy="731520"/>
-          </a:xfrm>
-          <a:prstGeom prst="rect">
-            <a:avLst/>
-          </a:prstGeom>
-          <a:noFill/>
-        </p:spPr>
-        <p:txBody>
-          <a:bodyPr wrap="square">
-            <a:spAutoFit/>
-          </a:bodyPr>
-          <a:lstStyle/>
-          <a:p>
-            <a:pPr algn="l">
-              <a:defRPr sz="3600" b="1">
+            <a:off x="914400" y="914400"/>
+            <a:ext cx="10058400" cy="594360"/>
+          </a:xfrm>
+          <a:prstGeom prst="rect">
+            <a:avLst/>
+          </a:prstGeom>
+          <a:noFill/>
+        </p:spPr>
+        <p:txBody>
+          <a:bodyPr wrap="square">
+            <a:spAutoFit/>
+          </a:bodyPr>
+          <a:lstStyle/>
+          <a:p>
+            <a:pPr algn="l">
+              <a:defRPr sz="3200" b="1">
                 <a:solidFill>
                   <a:srgbClr val="FFFFFF"/>
                 </a:solidFill>
@@ -12016,22 +11792,22 @@
         </p:nvSpPr>
         <p:spPr>
           <a:xfrm>
-            <a:off x="914400" y="1828800"/>
-            <a:ext cx="10058400" cy="457200"/>
-          </a:xfrm>
-          <a:prstGeom prst="rect">
-            <a:avLst/>
-          </a:prstGeom>
-          <a:noFill/>
-        </p:spPr>
-        <p:txBody>
-          <a:bodyPr wrap="square">
-            <a:spAutoFit/>
-          </a:bodyPr>
-          <a:lstStyle/>
-          <a:p>
-            <a:pPr algn="l">
-              <a:defRPr sz="1800" b="0">
+            <a:off x="914400" y="1600200"/>
+            <a:ext cx="10058400" cy="274320"/>
+          </a:xfrm>
+          <a:prstGeom prst="rect">
+            <a:avLst/>
+          </a:prstGeom>
+          <a:noFill/>
+        </p:spPr>
+        <p:txBody>
+          <a:bodyPr wrap="square">
+            <a:spAutoFit/>
+          </a:bodyPr>
+          <a:lstStyle/>
+          <a:p>
+            <a:pPr algn="l">
+              <a:defRPr sz="1400" b="0">
                 <a:solidFill>
                   <a:srgbClr val="9CA3AF"/>
                 </a:solidFill>
@@ -12051,7 +11827,7 @@
         </p:nvSpPr>
         <p:spPr>
           <a:xfrm>
-            <a:off x="731520" y="2103120"/>
+            <a:off x="731520" y="2377440"/>
             <a:ext cx="10515600" cy="594360"/>
           </a:xfrm>
           <a:prstGeom prst="roundRect">
@@ -12096,7 +11872,7 @@
         </p:nvSpPr>
         <p:spPr>
           <a:xfrm>
-            <a:off x="914400" y="2176272"/>
+            <a:off x="914400" y="2450592"/>
             <a:ext cx="10241280" cy="457200"/>
           </a:xfrm>
           <a:prstGeom prst="rect">
@@ -12131,7 +11907,7 @@
         </p:nvSpPr>
         <p:spPr>
           <a:xfrm>
-            <a:off x="731520" y="2816352"/>
+            <a:off x="731520" y="3090672"/>
             <a:ext cx="10515600" cy="594360"/>
           </a:xfrm>
           <a:prstGeom prst="roundRect">
@@ -12176,7 +11952,7 @@
         </p:nvSpPr>
         <p:spPr>
           <a:xfrm>
-            <a:off x="914400" y="2889504"/>
+            <a:off x="914400" y="3163824"/>
             <a:ext cx="10241280" cy="457200"/>
           </a:xfrm>
           <a:prstGeom prst="rect">
@@ -12211,7 +11987,7 @@
         </p:nvSpPr>
         <p:spPr>
           <a:xfrm>
-            <a:off x="731520" y="3529584"/>
+            <a:off x="731520" y="3803904"/>
             <a:ext cx="10515600" cy="594360"/>
           </a:xfrm>
           <a:prstGeom prst="roundRect">
@@ -12256,7 +12032,7 @@
         </p:nvSpPr>
         <p:spPr>
           <a:xfrm>
-            <a:off x="914400" y="3602736"/>
+            <a:off x="914400" y="3877056"/>
             <a:ext cx="10241280" cy="457200"/>
           </a:xfrm>
           <a:prstGeom prst="rect">
@@ -12291,7 +12067,7 @@
         </p:nvSpPr>
         <p:spPr>
           <a:xfrm>
-            <a:off x="731520" y="4242816"/>
+            <a:off x="731520" y="4517136"/>
             <a:ext cx="10515600" cy="594360"/>
           </a:xfrm>
           <a:prstGeom prst="roundRect">
@@ -12336,7 +12112,7 @@
         </p:nvSpPr>
         <p:spPr>
           <a:xfrm>
-            <a:off x="914400" y="4315968"/>
+            <a:off x="914400" y="4590288"/>
             <a:ext cx="10241280" cy="457200"/>
           </a:xfrm>
           <a:prstGeom prst="rect">
@@ -12371,7 +12147,7 @@
         </p:nvSpPr>
         <p:spPr>
           <a:xfrm>
-            <a:off x="731520" y="4956048"/>
+            <a:off x="731520" y="5230368"/>
             <a:ext cx="10515600" cy="594360"/>
           </a:xfrm>
           <a:prstGeom prst="roundRect">
@@ -12416,7 +12192,7 @@
         </p:nvSpPr>
         <p:spPr>
           <a:xfrm>
-            <a:off x="914400" y="5029200"/>
+            <a:off x="914400" y="5303520"/>
             <a:ext cx="10241280" cy="457200"/>
           </a:xfrm>
           <a:prstGeom prst="rect">
@@ -12451,7 +12227,7 @@
         </p:nvSpPr>
         <p:spPr>
           <a:xfrm>
-            <a:off x="731520" y="5669280"/>
+            <a:off x="731520" y="5943600"/>
             <a:ext cx="10515600" cy="594360"/>
           </a:xfrm>
           <a:prstGeom prst="roundRect">
@@ -12496,7 +12272,7 @@
         </p:nvSpPr>
         <p:spPr>
           <a:xfrm>
-            <a:off x="914400" y="5742432"/>
+            <a:off x="914400" y="6016752"/>
             <a:ext cx="10241280" cy="457200"/>
           </a:xfrm>
           <a:prstGeom prst="rect">
@@ -12643,22 +12419,22 @@
         </p:nvSpPr>
         <p:spPr>
           <a:xfrm>
-            <a:off x="914400" y="1097280"/>
-            <a:ext cx="10058400" cy="731520"/>
-          </a:xfrm>
-          <a:prstGeom prst="rect">
-            <a:avLst/>
-          </a:prstGeom>
-          <a:noFill/>
-        </p:spPr>
-        <p:txBody>
-          <a:bodyPr wrap="square">
-            <a:spAutoFit/>
-          </a:bodyPr>
-          <a:lstStyle/>
-          <a:p>
-            <a:pPr algn="l">
-              <a:defRPr sz="3600" b="1">
+            <a:off x="914400" y="914400"/>
+            <a:ext cx="10058400" cy="594360"/>
+          </a:xfrm>
+          <a:prstGeom prst="rect">
+            <a:avLst/>
+          </a:prstGeom>
+          <a:noFill/>
+        </p:spPr>
+        <p:txBody>
+          <a:bodyPr wrap="square">
+            <a:spAutoFit/>
+          </a:bodyPr>
+          <a:lstStyle/>
+          <a:p>
+            <a:pPr algn="l">
+              <a:defRPr sz="3200" b="1">
                 <a:solidFill>
                   <a:srgbClr val="FFFFFF"/>
                 </a:solidFill>
@@ -12678,7 +12454,7 @@
         </p:nvSpPr>
         <p:spPr>
           <a:xfrm>
-            <a:off x="914400" y="2194560"/>
+            <a:off x="914400" y="2103120"/>
             <a:ext cx="10058400" cy="4114800"/>
           </a:xfrm>
           <a:prstGeom prst="rect">
@@ -12972,22 +12748,22 @@
         </p:nvSpPr>
         <p:spPr>
           <a:xfrm>
-            <a:off x="914400" y="1097280"/>
-            <a:ext cx="10058400" cy="731520"/>
-          </a:xfrm>
-          <a:prstGeom prst="rect">
-            <a:avLst/>
-          </a:prstGeom>
-          <a:noFill/>
-        </p:spPr>
-        <p:txBody>
-          <a:bodyPr wrap="square">
-            <a:spAutoFit/>
-          </a:bodyPr>
-          <a:lstStyle/>
-          <a:p>
-            <a:pPr algn="l">
-              <a:defRPr sz="3600" b="1">
+            <a:off x="914400" y="914400"/>
+            <a:ext cx="10058400" cy="594360"/>
+          </a:xfrm>
+          <a:prstGeom prst="rect">
+            <a:avLst/>
+          </a:prstGeom>
+          <a:noFill/>
+        </p:spPr>
+        <p:txBody>
+          <a:bodyPr wrap="square">
+            <a:spAutoFit/>
+          </a:bodyPr>
+          <a:lstStyle/>
+          <a:p>
+            <a:pPr algn="l">
+              <a:defRPr sz="3200" b="1">
                 <a:solidFill>
                   <a:srgbClr val="FFFFFF"/>
                 </a:solidFill>
@@ -13007,22 +12783,22 @@
         </p:nvSpPr>
         <p:spPr>
           <a:xfrm>
-            <a:off x="914400" y="1828800"/>
-            <a:ext cx="10058400" cy="457200"/>
-          </a:xfrm>
-          <a:prstGeom prst="rect">
-            <a:avLst/>
-          </a:prstGeom>
-          <a:noFill/>
-        </p:spPr>
-        <p:txBody>
-          <a:bodyPr wrap="square">
-            <a:spAutoFit/>
-          </a:bodyPr>
-          <a:lstStyle/>
-          <a:p>
-            <a:pPr algn="l">
-              <a:defRPr sz="1800" b="0">
+            <a:off x="914400" y="1600200"/>
+            <a:ext cx="10058400" cy="274320"/>
+          </a:xfrm>
+          <a:prstGeom prst="rect">
+            <a:avLst/>
+          </a:prstGeom>
+          <a:noFill/>
+        </p:spPr>
+        <p:txBody>
+          <a:bodyPr wrap="square">
+            <a:spAutoFit/>
+          </a:bodyPr>
+          <a:lstStyle/>
+          <a:p>
+            <a:pPr algn="l">
+              <a:defRPr sz="1400" b="0">
                 <a:solidFill>
                   <a:srgbClr val="9CA3AF"/>
                 </a:solidFill>
@@ -13042,7 +12818,7 @@
         </p:nvSpPr>
         <p:spPr>
           <a:xfrm>
-            <a:off x="731520" y="2011680"/>
+            <a:off x="731520" y="2286000"/>
             <a:ext cx="3200400" cy="502920"/>
           </a:xfrm>
           <a:prstGeom prst="roundRect">
@@ -13087,7 +12863,7 @@
         </p:nvSpPr>
         <p:spPr>
           <a:xfrm>
-            <a:off x="822960" y="2084832"/>
+            <a:off x="822960" y="2359152"/>
             <a:ext cx="3017520" cy="365760"/>
           </a:xfrm>
           <a:prstGeom prst="rect">
@@ -13122,7 +12898,7 @@
         </p:nvSpPr>
         <p:spPr>
           <a:xfrm>
-            <a:off x="4114800" y="2084832"/>
+            <a:off x="4114800" y="2359152"/>
             <a:ext cx="7589520" cy="365760"/>
           </a:xfrm>
           <a:prstGeom prst="rect">
@@ -13157,7 +12933,7 @@
         </p:nvSpPr>
         <p:spPr>
           <a:xfrm>
-            <a:off x="731520" y="2606040"/>
+            <a:off x="731520" y="2880360"/>
             <a:ext cx="3200400" cy="502920"/>
           </a:xfrm>
           <a:prstGeom prst="roundRect">
@@ -13202,7 +12978,7 @@
         </p:nvSpPr>
         <p:spPr>
           <a:xfrm>
-            <a:off x="822960" y="2679192"/>
+            <a:off x="822960" y="2953512"/>
             <a:ext cx="3017520" cy="365760"/>
           </a:xfrm>
           <a:prstGeom prst="rect">
@@ -13237,7 +13013,7 @@
         </p:nvSpPr>
         <p:spPr>
           <a:xfrm>
-            <a:off x="4114800" y="2679192"/>
+            <a:off x="4114800" y="2953512"/>
             <a:ext cx="7589520" cy="365760"/>
           </a:xfrm>
           <a:prstGeom prst="rect">
@@ -13272,7 +13048,7 @@
         </p:nvSpPr>
         <p:spPr>
           <a:xfrm>
-            <a:off x="731520" y="3200400"/>
+            <a:off x="731520" y="3474720"/>
             <a:ext cx="3200400" cy="502920"/>
           </a:xfrm>
           <a:prstGeom prst="roundRect">
@@ -13317,7 +13093,7 @@
         </p:nvSpPr>
         <p:spPr>
           <a:xfrm>
-            <a:off x="822960" y="3273552"/>
+            <a:off x="822960" y="3547872"/>
             <a:ext cx="3017520" cy="365760"/>
           </a:xfrm>
           <a:prstGeom prst="rect">
@@ -13352,7 +13128,7 @@
         </p:nvSpPr>
         <p:spPr>
           <a:xfrm>
-            <a:off x="4114800" y="3273552"/>
+            <a:off x="4114800" y="3547872"/>
             <a:ext cx="7589520" cy="365760"/>
           </a:xfrm>
           <a:prstGeom prst="rect">
@@ -13387,7 +13163,7 @@
         </p:nvSpPr>
         <p:spPr>
           <a:xfrm>
-            <a:off x="731520" y="3794760"/>
+            <a:off x="731520" y="4069080"/>
             <a:ext cx="3200400" cy="502920"/>
           </a:xfrm>
           <a:prstGeom prst="roundRect">
@@ -13432,7 +13208,7 @@
         </p:nvSpPr>
         <p:spPr>
           <a:xfrm>
-            <a:off x="822960" y="3867912"/>
+            <a:off x="822960" y="4142232"/>
             <a:ext cx="3017520" cy="365760"/>
           </a:xfrm>
           <a:prstGeom prst="rect">
@@ -13467,7 +13243,7 @@
         </p:nvSpPr>
         <p:spPr>
           <a:xfrm>
-            <a:off x="4114800" y="3867912"/>
+            <a:off x="4114800" y="4142232"/>
             <a:ext cx="7589520" cy="365760"/>
           </a:xfrm>
           <a:prstGeom prst="rect">
@@ -13502,7 +13278,7 @@
         </p:nvSpPr>
         <p:spPr>
           <a:xfrm>
-            <a:off x="731520" y="4389120"/>
+            <a:off x="731520" y="4663440"/>
             <a:ext cx="3200400" cy="502920"/>
           </a:xfrm>
           <a:prstGeom prst="roundRect">
@@ -13547,7 +13323,7 @@
         </p:nvSpPr>
         <p:spPr>
           <a:xfrm>
-            <a:off x="822960" y="4462272"/>
+            <a:off x="822960" y="4736592"/>
             <a:ext cx="3017520" cy="365760"/>
           </a:xfrm>
           <a:prstGeom prst="rect">
@@ -13582,7 +13358,7 @@
         </p:nvSpPr>
         <p:spPr>
           <a:xfrm>
-            <a:off x="4114800" y="4462272"/>
+            <a:off x="4114800" y="4736592"/>
             <a:ext cx="7589520" cy="365760"/>
           </a:xfrm>
           <a:prstGeom prst="rect">
@@ -13617,7 +13393,7 @@
         </p:nvSpPr>
         <p:spPr>
           <a:xfrm>
-            <a:off x="731520" y="4983480"/>
+            <a:off x="731520" y="5257800"/>
             <a:ext cx="3200400" cy="502920"/>
           </a:xfrm>
           <a:prstGeom prst="roundRect">
@@ -13662,7 +13438,7 @@
         </p:nvSpPr>
         <p:spPr>
           <a:xfrm>
-            <a:off x="822960" y="5056632"/>
+            <a:off x="822960" y="5330952"/>
             <a:ext cx="3017520" cy="365760"/>
           </a:xfrm>
           <a:prstGeom prst="rect">
@@ -13697,7 +13473,7 @@
         </p:nvSpPr>
         <p:spPr>
           <a:xfrm>
-            <a:off x="4114800" y="5056632"/>
+            <a:off x="4114800" y="5330952"/>
             <a:ext cx="7589520" cy="365760"/>
           </a:xfrm>
           <a:prstGeom prst="rect">
@@ -13732,7 +13508,7 @@
         </p:nvSpPr>
         <p:spPr>
           <a:xfrm>
-            <a:off x="731520" y="5577840"/>
+            <a:off x="731520" y="5852160"/>
             <a:ext cx="3200400" cy="502920"/>
           </a:xfrm>
           <a:prstGeom prst="roundRect">
@@ -13777,7 +13553,7 @@
         </p:nvSpPr>
         <p:spPr>
           <a:xfrm>
-            <a:off x="822960" y="5650992"/>
+            <a:off x="822960" y="5925312"/>
             <a:ext cx="3017520" cy="365760"/>
           </a:xfrm>
           <a:prstGeom prst="rect">
@@ -13812,7 +13588,7 @@
         </p:nvSpPr>
         <p:spPr>
           <a:xfrm>
-            <a:off x="4114800" y="5650992"/>
+            <a:off x="4114800" y="5925312"/>
             <a:ext cx="7589520" cy="365760"/>
           </a:xfrm>
           <a:prstGeom prst="rect">
@@ -14180,22 +13956,22 @@
         </p:nvSpPr>
         <p:spPr>
           <a:xfrm>
-            <a:off x="914400" y="1097280"/>
-            <a:ext cx="10058400" cy="731520"/>
-          </a:xfrm>
-          <a:prstGeom prst="rect">
-            <a:avLst/>
-          </a:prstGeom>
-          <a:noFill/>
-        </p:spPr>
-        <p:txBody>
-          <a:bodyPr wrap="square">
-            <a:spAutoFit/>
-          </a:bodyPr>
-          <a:lstStyle/>
-          <a:p>
-            <a:pPr algn="l">
-              <a:defRPr sz="3600" b="1">
+            <a:off x="914400" y="914400"/>
+            <a:ext cx="10058400" cy="594360"/>
+          </a:xfrm>
+          <a:prstGeom prst="rect">
+            <a:avLst/>
+          </a:prstGeom>
+          <a:noFill/>
+        </p:spPr>
+        <p:txBody>
+          <a:bodyPr wrap="square">
+            <a:spAutoFit/>
+          </a:bodyPr>
+          <a:lstStyle/>
+          <a:p>
+            <a:pPr algn="l">
+              <a:defRPr sz="3200" b="1">
                 <a:solidFill>
                   <a:srgbClr val="FFFFFF"/>
                 </a:solidFill>
@@ -14215,22 +13991,22 @@
         </p:nvSpPr>
         <p:spPr>
           <a:xfrm>
-            <a:off x="914400" y="1828800"/>
-            <a:ext cx="10058400" cy="457200"/>
-          </a:xfrm>
-          <a:prstGeom prst="rect">
-            <a:avLst/>
-          </a:prstGeom>
-          <a:noFill/>
-        </p:spPr>
-        <p:txBody>
-          <a:bodyPr wrap="square">
-            <a:spAutoFit/>
-          </a:bodyPr>
-          <a:lstStyle/>
-          <a:p>
-            <a:pPr algn="l">
-              <a:defRPr sz="1800" b="0">
+            <a:off x="914400" y="1600200"/>
+            <a:ext cx="10058400" cy="274320"/>
+          </a:xfrm>
+          <a:prstGeom prst="rect">
+            <a:avLst/>
+          </a:prstGeom>
+          <a:noFill/>
+        </p:spPr>
+        <p:txBody>
+          <a:bodyPr wrap="square">
+            <a:spAutoFit/>
+          </a:bodyPr>
+          <a:lstStyle/>
+          <a:p>
+            <a:pPr algn="l">
+              <a:defRPr sz="1400" b="0">
                 <a:solidFill>
                   <a:srgbClr val="9CA3AF"/>
                 </a:solidFill>
@@ -14250,7 +14026,7 @@
         </p:nvSpPr>
         <p:spPr>
           <a:xfrm>
-            <a:off x="548640" y="2011680"/>
+            <a:off x="548640" y="2286000"/>
             <a:ext cx="5394960" cy="1005840"/>
           </a:xfrm>
           <a:prstGeom prst="roundRect">
@@ -14295,7 +14071,7 @@
         </p:nvSpPr>
         <p:spPr>
           <a:xfrm>
-            <a:off x="731520" y="2103120"/>
+            <a:off x="731520" y="2377440"/>
             <a:ext cx="5029200" cy="320040"/>
           </a:xfrm>
           <a:prstGeom prst="rect">
@@ -14330,7 +14106,7 @@
         </p:nvSpPr>
         <p:spPr>
           <a:xfrm>
-            <a:off x="731520" y="2468880"/>
+            <a:off x="731520" y="2743200"/>
             <a:ext cx="5029200" cy="457200"/>
           </a:xfrm>
           <a:prstGeom prst="rect">
@@ -14365,7 +14141,7 @@
         </p:nvSpPr>
         <p:spPr>
           <a:xfrm>
-            <a:off x="6309360" y="2011680"/>
+            <a:off x="6309360" y="2286000"/>
             <a:ext cx="5394960" cy="1005840"/>
           </a:xfrm>
           <a:prstGeom prst="roundRect">
@@ -14410,7 +14186,7 @@
         </p:nvSpPr>
         <p:spPr>
           <a:xfrm>
-            <a:off x="6492240" y="2103120"/>
+            <a:off x="6492240" y="2377440"/>
             <a:ext cx="5029200" cy="320040"/>
           </a:xfrm>
           <a:prstGeom prst="rect">
@@ -14445,7 +14221,7 @@
         </p:nvSpPr>
         <p:spPr>
           <a:xfrm>
-            <a:off x="6492240" y="2468880"/>
+            <a:off x="6492240" y="2743200"/>
             <a:ext cx="5029200" cy="457200"/>
           </a:xfrm>
           <a:prstGeom prst="rect">
@@ -14480,7 +14256,7 @@
         </p:nvSpPr>
         <p:spPr>
           <a:xfrm>
-            <a:off x="548640" y="3200400"/>
+            <a:off x="548640" y="3474720"/>
             <a:ext cx="5394960" cy="1005840"/>
           </a:xfrm>
           <a:prstGeom prst="roundRect">
@@ -14525,7 +14301,7 @@
         </p:nvSpPr>
         <p:spPr>
           <a:xfrm>
-            <a:off x="731520" y="3291840"/>
+            <a:off x="731520" y="3566160"/>
             <a:ext cx="5029200" cy="320040"/>
           </a:xfrm>
           <a:prstGeom prst="rect">
@@ -14560,7 +14336,7 @@
         </p:nvSpPr>
         <p:spPr>
           <a:xfrm>
-            <a:off x="731520" y="3657600"/>
+            <a:off x="731520" y="3931920"/>
             <a:ext cx="5029200" cy="457200"/>
           </a:xfrm>
           <a:prstGeom prst="rect">
@@ -14595,7 +14371,7 @@
         </p:nvSpPr>
         <p:spPr>
           <a:xfrm>
-            <a:off x="6309360" y="3200400"/>
+            <a:off x="6309360" y="3474720"/>
             <a:ext cx="5394960" cy="1005840"/>
           </a:xfrm>
           <a:prstGeom prst="roundRect">
@@ -14640,7 +14416,7 @@
         </p:nvSpPr>
         <p:spPr>
           <a:xfrm>
-            <a:off x="6492240" y="3291840"/>
+            <a:off x="6492240" y="3566160"/>
             <a:ext cx="5029200" cy="320040"/>
           </a:xfrm>
           <a:prstGeom prst="rect">
@@ -14675,7 +14451,7 @@
         </p:nvSpPr>
         <p:spPr>
           <a:xfrm>
-            <a:off x="6492240" y="3657600"/>
+            <a:off x="6492240" y="3931920"/>
             <a:ext cx="5029200" cy="457200"/>
           </a:xfrm>
           <a:prstGeom prst="rect">
@@ -14710,7 +14486,7 @@
         </p:nvSpPr>
         <p:spPr>
           <a:xfrm>
-            <a:off x="548640" y="4389120"/>
+            <a:off x="548640" y="4663440"/>
             <a:ext cx="5394960" cy="1005840"/>
           </a:xfrm>
           <a:prstGeom prst="roundRect">
@@ -14755,7 +14531,7 @@
         </p:nvSpPr>
         <p:spPr>
           <a:xfrm>
-            <a:off x="731520" y="4480560"/>
+            <a:off x="731520" y="4754880"/>
             <a:ext cx="5029200" cy="320040"/>
           </a:xfrm>
           <a:prstGeom prst="rect">
@@ -14790,7 +14566,7 @@
         </p:nvSpPr>
         <p:spPr>
           <a:xfrm>
-            <a:off x="731520" y="4846320"/>
+            <a:off x="731520" y="5120640"/>
             <a:ext cx="5029200" cy="457200"/>
           </a:xfrm>
           <a:prstGeom prst="rect">
@@ -14825,7 +14601,7 @@
         </p:nvSpPr>
         <p:spPr>
           <a:xfrm>
-            <a:off x="6309360" y="4389120"/>
+            <a:off x="6309360" y="4663440"/>
             <a:ext cx="5394960" cy="1005840"/>
           </a:xfrm>
           <a:prstGeom prst="roundRect">
@@ -14870,7 +14646,7 @@
         </p:nvSpPr>
         <p:spPr>
           <a:xfrm>
-            <a:off x="6492240" y="4480560"/>
+            <a:off x="6492240" y="4754880"/>
             <a:ext cx="5029200" cy="320040"/>
           </a:xfrm>
           <a:prstGeom prst="rect">
@@ -14905,7 +14681,7 @@
         </p:nvSpPr>
         <p:spPr>
           <a:xfrm>
-            <a:off x="6492240" y="4846320"/>
+            <a:off x="6492240" y="5120640"/>
             <a:ext cx="5029200" cy="457200"/>
           </a:xfrm>
           <a:prstGeom prst="rect">
@@ -14940,7 +14716,7 @@
         </p:nvSpPr>
         <p:spPr>
           <a:xfrm>
-            <a:off x="548640" y="5577840"/>
+            <a:off x="548640" y="5852160"/>
             <a:ext cx="5394960" cy="1005840"/>
           </a:xfrm>
           <a:prstGeom prst="roundRect">
@@ -14985,7 +14761,7 @@
         </p:nvSpPr>
         <p:spPr>
           <a:xfrm>
-            <a:off x="731520" y="5669280"/>
+            <a:off x="731520" y="5943600"/>
             <a:ext cx="5029200" cy="320040"/>
           </a:xfrm>
           <a:prstGeom prst="rect">
@@ -15020,7 +14796,7 @@
         </p:nvSpPr>
         <p:spPr>
           <a:xfrm>
-            <a:off x="731520" y="6035040"/>
+            <a:off x="731520" y="6309360"/>
             <a:ext cx="5029200" cy="457200"/>
           </a:xfrm>
           <a:prstGeom prst="rect">
@@ -15167,22 +14943,22 @@
         </p:nvSpPr>
         <p:spPr>
           <a:xfrm>
-            <a:off x="914400" y="1097280"/>
-            <a:ext cx="10058400" cy="731520"/>
-          </a:xfrm>
-          <a:prstGeom prst="rect">
-            <a:avLst/>
-          </a:prstGeom>
-          <a:noFill/>
-        </p:spPr>
-        <p:txBody>
-          <a:bodyPr wrap="square">
-            <a:spAutoFit/>
-          </a:bodyPr>
-          <a:lstStyle/>
-          <a:p>
-            <a:pPr algn="l">
-              <a:defRPr sz="3600" b="1">
+            <a:off x="914400" y="914400"/>
+            <a:ext cx="10058400" cy="594360"/>
+          </a:xfrm>
+          <a:prstGeom prst="rect">
+            <a:avLst/>
+          </a:prstGeom>
+          <a:noFill/>
+        </p:spPr>
+        <p:txBody>
+          <a:bodyPr wrap="square">
+            <a:spAutoFit/>
+          </a:bodyPr>
+          <a:lstStyle/>
+          <a:p>
+            <a:pPr algn="l">
+              <a:defRPr sz="3200" b="1">
                 <a:solidFill>
                   <a:srgbClr val="FFFFFF"/>
                 </a:solidFill>
@@ -15202,22 +14978,22 @@
         </p:nvSpPr>
         <p:spPr>
           <a:xfrm>
-            <a:off x="914400" y="1828800"/>
-            <a:ext cx="10058400" cy="457200"/>
-          </a:xfrm>
-          <a:prstGeom prst="rect">
-            <a:avLst/>
-          </a:prstGeom>
-          <a:noFill/>
-        </p:spPr>
-        <p:txBody>
-          <a:bodyPr wrap="square">
-            <a:spAutoFit/>
-          </a:bodyPr>
-          <a:lstStyle/>
-          <a:p>
-            <a:pPr algn="l">
-              <a:defRPr sz="1800" b="0">
+            <a:off x="914400" y="1600200"/>
+            <a:ext cx="10058400" cy="274320"/>
+          </a:xfrm>
+          <a:prstGeom prst="rect">
+            <a:avLst/>
+          </a:prstGeom>
+          <a:noFill/>
+        </p:spPr>
+        <p:txBody>
+          <a:bodyPr wrap="square">
+            <a:spAutoFit/>
+          </a:bodyPr>
+          <a:lstStyle/>
+          <a:p>
+            <a:pPr algn="l">
+              <a:defRPr sz="1400" b="0">
                 <a:solidFill>
                   <a:srgbClr val="9CA3AF"/>
                 </a:solidFill>
@@ -15237,7 +15013,7 @@
         </p:nvSpPr>
         <p:spPr>
           <a:xfrm>
-            <a:off x="457200" y="2103120"/>
+            <a:off x="457200" y="2377440"/>
             <a:ext cx="3566160" cy="1645920"/>
           </a:xfrm>
           <a:prstGeom prst="roundRect">
@@ -15282,7 +15058,7 @@
         </p:nvSpPr>
         <p:spPr>
           <a:xfrm>
-            <a:off x="457200" y="2103120"/>
+            <a:off x="457200" y="2377440"/>
             <a:ext cx="3566160" cy="36576"/>
           </a:xfrm>
           <a:prstGeom prst="rect">
@@ -15325,7 +15101,7 @@
         </p:nvSpPr>
         <p:spPr>
           <a:xfrm>
-            <a:off x="594360" y="2240280"/>
+            <a:off x="594360" y="2514600"/>
             <a:ext cx="3291840" cy="365760"/>
           </a:xfrm>
           <a:prstGeom prst="rect">
@@ -15360,7 +15136,7 @@
         </p:nvSpPr>
         <p:spPr>
           <a:xfrm>
-            <a:off x="594360" y="2651760"/>
+            <a:off x="594360" y="2926080"/>
             <a:ext cx="3291840" cy="914400"/>
           </a:xfrm>
           <a:prstGeom prst="rect">
@@ -15395,7 +15171,7 @@
         </p:nvSpPr>
         <p:spPr>
           <a:xfrm>
-            <a:off x="4297680" y="2103120"/>
+            <a:off x="4297680" y="2377440"/>
             <a:ext cx="3566160" cy="1645920"/>
           </a:xfrm>
           <a:prstGeom prst="roundRect">
@@ -15440,7 +15216,7 @@
         </p:nvSpPr>
         <p:spPr>
           <a:xfrm>
-            <a:off x="4297680" y="2103120"/>
+            <a:off x="4297680" y="2377440"/>
             <a:ext cx="3566160" cy="36576"/>
           </a:xfrm>
           <a:prstGeom prst="rect">
@@ -15483,7 +15259,7 @@
         </p:nvSpPr>
         <p:spPr>
           <a:xfrm>
-            <a:off x="4434840" y="2240280"/>
+            <a:off x="4434840" y="2514600"/>
             <a:ext cx="3291840" cy="365760"/>
           </a:xfrm>
           <a:prstGeom prst="rect">
@@ -15518,7 +15294,7 @@
         </p:nvSpPr>
         <p:spPr>
           <a:xfrm>
-            <a:off x="4434840" y="2651760"/>
+            <a:off x="4434840" y="2926080"/>
             <a:ext cx="3291840" cy="914400"/>
           </a:xfrm>
           <a:prstGeom prst="rect">
@@ -15553,7 +15329,7 @@
         </p:nvSpPr>
         <p:spPr>
           <a:xfrm>
-            <a:off x="8138160" y="2103120"/>
+            <a:off x="8138160" y="2377440"/>
             <a:ext cx="3566160" cy="1645920"/>
           </a:xfrm>
           <a:prstGeom prst="roundRect">
@@ -15598,7 +15374,7 @@
         </p:nvSpPr>
         <p:spPr>
           <a:xfrm>
-            <a:off x="8138160" y="2103120"/>
+            <a:off x="8138160" y="2377440"/>
             <a:ext cx="3566160" cy="36576"/>
           </a:xfrm>
           <a:prstGeom prst="rect">
@@ -15641,7 +15417,7 @@
         </p:nvSpPr>
         <p:spPr>
           <a:xfrm>
-            <a:off x="8275320" y="2240280"/>
+            <a:off x="8275320" y="2514600"/>
             <a:ext cx="3291840" cy="365760"/>
           </a:xfrm>
           <a:prstGeom prst="rect">
@@ -15676,7 +15452,7 @@
         </p:nvSpPr>
         <p:spPr>
           <a:xfrm>
-            <a:off x="8275320" y="2651760"/>
+            <a:off x="8275320" y="2926080"/>
             <a:ext cx="3291840" cy="914400"/>
           </a:xfrm>
           <a:prstGeom prst="rect">
@@ -15711,7 +15487,7 @@
         </p:nvSpPr>
         <p:spPr>
           <a:xfrm>
-            <a:off x="457200" y="4114800"/>
+            <a:off x="457200" y="4389120"/>
             <a:ext cx="3566160" cy="1645920"/>
           </a:xfrm>
           <a:prstGeom prst="roundRect">
@@ -15756,7 +15532,7 @@
         </p:nvSpPr>
         <p:spPr>
           <a:xfrm>
-            <a:off x="457200" y="4114800"/>
+            <a:off x="457200" y="4389120"/>
             <a:ext cx="3566160" cy="36576"/>
           </a:xfrm>
           <a:prstGeom prst="rect">
@@ -15799,7 +15575,7 @@
         </p:nvSpPr>
         <p:spPr>
           <a:xfrm>
-            <a:off x="594360" y="4251960"/>
+            <a:off x="594360" y="4526280"/>
             <a:ext cx="3291840" cy="365760"/>
           </a:xfrm>
           <a:prstGeom prst="rect">
@@ -15834,7 +15610,7 @@
         </p:nvSpPr>
         <p:spPr>
           <a:xfrm>
-            <a:off x="594360" y="4663440"/>
+            <a:off x="594360" y="4937760"/>
             <a:ext cx="3291840" cy="914400"/>
           </a:xfrm>
           <a:prstGeom prst="rect">
@@ -15869,7 +15645,7 @@
         </p:nvSpPr>
         <p:spPr>
           <a:xfrm>
-            <a:off x="4297680" y="4114800"/>
+            <a:off x="4297680" y="4389120"/>
             <a:ext cx="3566160" cy="1645920"/>
           </a:xfrm>
           <a:prstGeom prst="roundRect">
@@ -15914,7 +15690,7 @@
         </p:nvSpPr>
         <p:spPr>
           <a:xfrm>
-            <a:off x="4297680" y="4114800"/>
+            <a:off x="4297680" y="4389120"/>
             <a:ext cx="3566160" cy="36576"/>
           </a:xfrm>
           <a:prstGeom prst="rect">
@@ -15957,7 +15733,7 @@
         </p:nvSpPr>
         <p:spPr>
           <a:xfrm>
-            <a:off x="4434840" y="4251960"/>
+            <a:off x="4434840" y="4526280"/>
             <a:ext cx="3291840" cy="365760"/>
           </a:xfrm>
           <a:prstGeom prst="rect">
@@ -15992,7 +15768,7 @@
         </p:nvSpPr>
         <p:spPr>
           <a:xfrm>
-            <a:off x="4434840" y="4663440"/>
+            <a:off x="4434840" y="4937760"/>
             <a:ext cx="3291840" cy="914400"/>
           </a:xfrm>
           <a:prstGeom prst="rect">
@@ -16027,7 +15803,7 @@
         </p:nvSpPr>
         <p:spPr>
           <a:xfrm>
-            <a:off x="8138160" y="4114800"/>
+            <a:off x="8138160" y="4389120"/>
             <a:ext cx="3566160" cy="1645920"/>
           </a:xfrm>
           <a:prstGeom prst="roundRect">
@@ -16072,7 +15848,7 @@
         </p:nvSpPr>
         <p:spPr>
           <a:xfrm>
-            <a:off x="8138160" y="4114800"/>
+            <a:off x="8138160" y="4389120"/>
             <a:ext cx="3566160" cy="36576"/>
           </a:xfrm>
           <a:prstGeom prst="rect">
@@ -16115,7 +15891,7 @@
         </p:nvSpPr>
         <p:spPr>
           <a:xfrm>
-            <a:off x="8275320" y="4251960"/>
+            <a:off x="8275320" y="4526280"/>
             <a:ext cx="3291840" cy="365760"/>
           </a:xfrm>
           <a:prstGeom prst="rect">
@@ -16150,7 +15926,7 @@
         </p:nvSpPr>
         <p:spPr>
           <a:xfrm>
-            <a:off x="8275320" y="4663440"/>
+            <a:off x="8275320" y="4937760"/>
             <a:ext cx="3291840" cy="914400"/>
           </a:xfrm>
           <a:prstGeom prst="rect">
@@ -16297,22 +16073,22 @@
         </p:nvSpPr>
         <p:spPr>
           <a:xfrm>
-            <a:off x="914400" y="1097280"/>
-            <a:ext cx="10058400" cy="731520"/>
-          </a:xfrm>
-          <a:prstGeom prst="rect">
-            <a:avLst/>
-          </a:prstGeom>
-          <a:noFill/>
-        </p:spPr>
-        <p:txBody>
-          <a:bodyPr wrap="square">
-            <a:spAutoFit/>
-          </a:bodyPr>
-          <a:lstStyle/>
-          <a:p>
-            <a:pPr algn="l">
-              <a:defRPr sz="3600" b="1">
+            <a:off x="914400" y="914400"/>
+            <a:ext cx="10058400" cy="594360"/>
+          </a:xfrm>
+          <a:prstGeom prst="rect">
+            <a:avLst/>
+          </a:prstGeom>
+          <a:noFill/>
+        </p:spPr>
+        <p:txBody>
+          <a:bodyPr wrap="square">
+            <a:spAutoFit/>
+          </a:bodyPr>
+          <a:lstStyle/>
+          <a:p>
+            <a:pPr algn="l">
+              <a:defRPr sz="3200" b="1">
                 <a:solidFill>
                   <a:srgbClr val="FFFFFF"/>
                 </a:solidFill>
@@ -16332,22 +16108,22 @@
         </p:nvSpPr>
         <p:spPr>
           <a:xfrm>
-            <a:off x="914400" y="1828800"/>
-            <a:ext cx="10058400" cy="457200"/>
-          </a:xfrm>
-          <a:prstGeom prst="rect">
-            <a:avLst/>
-          </a:prstGeom>
-          <a:noFill/>
-        </p:spPr>
-        <p:txBody>
-          <a:bodyPr wrap="square">
-            <a:spAutoFit/>
-          </a:bodyPr>
-          <a:lstStyle/>
-          <a:p>
-            <a:pPr algn="l">
-              <a:defRPr sz="1800" b="0">
+            <a:off x="914400" y="1600200"/>
+            <a:ext cx="10058400" cy="274320"/>
+          </a:xfrm>
+          <a:prstGeom prst="rect">
+            <a:avLst/>
+          </a:prstGeom>
+          <a:noFill/>
+        </p:spPr>
+        <p:txBody>
+          <a:bodyPr wrap="square">
+            <a:spAutoFit/>
+          </a:bodyPr>
+          <a:lstStyle/>
+          <a:p>
+            <a:pPr algn="l">
+              <a:defRPr sz="1400" b="0">
                 <a:solidFill>
                   <a:srgbClr val="9CA3AF"/>
                 </a:solidFill>
@@ -16367,7 +16143,7 @@
         </p:nvSpPr>
         <p:spPr>
           <a:xfrm>
-            <a:off x="731520" y="2103120"/>
+            <a:off x="731520" y="2377440"/>
             <a:ext cx="10515600" cy="502920"/>
           </a:xfrm>
           <a:prstGeom prst="roundRect">
@@ -16412,7 +16188,7 @@
         </p:nvSpPr>
         <p:spPr>
           <a:xfrm>
-            <a:off x="914400" y="2148840"/>
+            <a:off x="914400" y="2423160"/>
             <a:ext cx="10241280" cy="365760"/>
           </a:xfrm>
           <a:prstGeom prst="rect">
@@ -16447,7 +16223,7 @@
         </p:nvSpPr>
         <p:spPr>
           <a:xfrm>
-            <a:off x="731520" y="2697480"/>
+            <a:off x="731520" y="2971800"/>
             <a:ext cx="10515600" cy="502920"/>
           </a:xfrm>
           <a:prstGeom prst="roundRect">
@@ -16492,7 +16268,7 @@
         </p:nvSpPr>
         <p:spPr>
           <a:xfrm>
-            <a:off x="914400" y="2743200"/>
+            <a:off x="914400" y="3017520"/>
             <a:ext cx="10241280" cy="365760"/>
           </a:xfrm>
           <a:prstGeom prst="rect">
@@ -16527,7 +16303,7 @@
         </p:nvSpPr>
         <p:spPr>
           <a:xfrm>
-            <a:off x="731520" y="3291840"/>
+            <a:off x="731520" y="3566160"/>
             <a:ext cx="10515600" cy="502920"/>
           </a:xfrm>
           <a:prstGeom prst="roundRect">
@@ -16572,7 +16348,7 @@
         </p:nvSpPr>
         <p:spPr>
           <a:xfrm>
-            <a:off x="914400" y="3337560"/>
+            <a:off x="914400" y="3611880"/>
             <a:ext cx="10241280" cy="365760"/>
           </a:xfrm>
           <a:prstGeom prst="rect">
@@ -16607,7 +16383,7 @@
         </p:nvSpPr>
         <p:spPr>
           <a:xfrm>
-            <a:off x="731520" y="3886200"/>
+            <a:off x="731520" y="4160520"/>
             <a:ext cx="10515600" cy="502920"/>
           </a:xfrm>
           <a:prstGeom prst="roundRect">
@@ -16652,7 +16428,7 @@
         </p:nvSpPr>
         <p:spPr>
           <a:xfrm>
-            <a:off x="914400" y="3931920"/>
+            <a:off x="914400" y="4206240"/>
             <a:ext cx="10241280" cy="365760"/>
           </a:xfrm>
           <a:prstGeom prst="rect">
@@ -16687,7 +16463,7 @@
         </p:nvSpPr>
         <p:spPr>
           <a:xfrm>
-            <a:off x="731520" y="4480560"/>
+            <a:off x="731520" y="4754880"/>
             <a:ext cx="10515600" cy="502920"/>
           </a:xfrm>
           <a:prstGeom prst="roundRect">
@@ -16732,7 +16508,7 @@
         </p:nvSpPr>
         <p:spPr>
           <a:xfrm>
-            <a:off x="914400" y="4526280"/>
+            <a:off x="914400" y="4800600"/>
             <a:ext cx="10241280" cy="365760"/>
           </a:xfrm>
           <a:prstGeom prst="rect">
@@ -16767,7 +16543,7 @@
         </p:nvSpPr>
         <p:spPr>
           <a:xfrm>
-            <a:off x="731520" y="5074920"/>
+            <a:off x="731520" y="5349240"/>
             <a:ext cx="10515600" cy="502920"/>
           </a:xfrm>
           <a:prstGeom prst="roundRect">
@@ -16812,7 +16588,7 @@
         </p:nvSpPr>
         <p:spPr>
           <a:xfrm>
-            <a:off x="914400" y="5120640"/>
+            <a:off x="914400" y="5394960"/>
             <a:ext cx="10241280" cy="365760"/>
           </a:xfrm>
           <a:prstGeom prst="rect">
@@ -16847,7 +16623,7 @@
         </p:nvSpPr>
         <p:spPr>
           <a:xfrm>
-            <a:off x="731520" y="5669280"/>
+            <a:off x="731520" y="5943600"/>
             <a:ext cx="10515600" cy="502920"/>
           </a:xfrm>
           <a:prstGeom prst="roundRect">
@@ -16892,7 +16668,7 @@
         </p:nvSpPr>
         <p:spPr>
           <a:xfrm>
-            <a:off x="914400" y="5715000"/>
+            <a:off x="914400" y="5989320"/>
             <a:ext cx="10241280" cy="365760"/>
           </a:xfrm>
           <a:prstGeom prst="rect">
@@ -17039,22 +16815,22 @@
         </p:nvSpPr>
         <p:spPr>
           <a:xfrm>
-            <a:off x="914400" y="1097280"/>
-            <a:ext cx="10058400" cy="731520"/>
-          </a:xfrm>
-          <a:prstGeom prst="rect">
-            <a:avLst/>
-          </a:prstGeom>
-          <a:noFill/>
-        </p:spPr>
-        <p:txBody>
-          <a:bodyPr wrap="square">
-            <a:spAutoFit/>
-          </a:bodyPr>
-          <a:lstStyle/>
-          <a:p>
-            <a:pPr algn="l">
-              <a:defRPr sz="3600" b="1">
+            <a:off x="914400" y="914400"/>
+            <a:ext cx="10058400" cy="594360"/>
+          </a:xfrm>
+          <a:prstGeom prst="rect">
+            <a:avLst/>
+          </a:prstGeom>
+          <a:noFill/>
+        </p:spPr>
+        <p:txBody>
+          <a:bodyPr wrap="square">
+            <a:spAutoFit/>
+          </a:bodyPr>
+          <a:lstStyle/>
+          <a:p>
+            <a:pPr algn="l">
+              <a:defRPr sz="3200" b="1">
                 <a:solidFill>
                   <a:srgbClr val="FFFFFF"/>
                 </a:solidFill>
@@ -17074,22 +16850,22 @@
         </p:nvSpPr>
         <p:spPr>
           <a:xfrm>
-            <a:off x="914400" y="1828800"/>
-            <a:ext cx="10058400" cy="457200"/>
-          </a:xfrm>
-          <a:prstGeom prst="rect">
-            <a:avLst/>
-          </a:prstGeom>
-          <a:noFill/>
-        </p:spPr>
-        <p:txBody>
-          <a:bodyPr wrap="square">
-            <a:spAutoFit/>
-          </a:bodyPr>
-          <a:lstStyle/>
-          <a:p>
-            <a:pPr algn="l">
-              <a:defRPr sz="1800" b="0">
+            <a:off x="914400" y="1600200"/>
+            <a:ext cx="10058400" cy="274320"/>
+          </a:xfrm>
+          <a:prstGeom prst="rect">
+            <a:avLst/>
+          </a:prstGeom>
+          <a:noFill/>
+        </p:spPr>
+        <p:txBody>
+          <a:bodyPr wrap="square">
+            <a:spAutoFit/>
+          </a:bodyPr>
+          <a:lstStyle/>
+          <a:p>
+            <a:pPr algn="l">
+              <a:defRPr sz="1400" b="0">
                 <a:solidFill>
                   <a:srgbClr val="9CA3AF"/>
                 </a:solidFill>
@@ -17109,7 +16885,7 @@
         </p:nvSpPr>
         <p:spPr>
           <a:xfrm>
-            <a:off x="365760" y="1920240"/>
+            <a:off x="365760" y="2194560"/>
             <a:ext cx="2743200" cy="1920240"/>
           </a:xfrm>
           <a:prstGeom prst="roundRect">
@@ -17154,7 +16930,7 @@
         </p:nvSpPr>
         <p:spPr>
           <a:xfrm>
-            <a:off x="365760" y="1920240"/>
+            <a:off x="365760" y="2194560"/>
             <a:ext cx="2743200" cy="36576"/>
           </a:xfrm>
           <a:prstGeom prst="rect">
@@ -17197,7 +16973,7 @@
         </p:nvSpPr>
         <p:spPr>
           <a:xfrm>
-            <a:off x="457200" y="2057400"/>
+            <a:off x="457200" y="2331720"/>
             <a:ext cx="2560320" cy="320040"/>
           </a:xfrm>
           <a:prstGeom prst="rect">
@@ -17232,7 +17008,7 @@
         </p:nvSpPr>
         <p:spPr>
           <a:xfrm>
-            <a:off x="457200" y="2423160"/>
+            <a:off x="457200" y="2697480"/>
             <a:ext cx="2560320" cy="1188720"/>
           </a:xfrm>
           <a:prstGeom prst="rect">
@@ -17275,7 +17051,7 @@
         </p:nvSpPr>
         <p:spPr>
           <a:xfrm>
-            <a:off x="3291840" y="1920240"/>
+            <a:off x="3291840" y="2194560"/>
             <a:ext cx="2743200" cy="1920240"/>
           </a:xfrm>
           <a:prstGeom prst="roundRect">
@@ -17320,7 +17096,7 @@
         </p:nvSpPr>
         <p:spPr>
           <a:xfrm>
-            <a:off x="3291840" y="1920240"/>
+            <a:off x="3291840" y="2194560"/>
             <a:ext cx="2743200" cy="36576"/>
           </a:xfrm>
           <a:prstGeom prst="rect">
@@ -17363,7 +17139,7 @@
         </p:nvSpPr>
         <p:spPr>
           <a:xfrm>
-            <a:off x="3383280" y="2057400"/>
+            <a:off x="3383280" y="2331720"/>
             <a:ext cx="2560320" cy="320040"/>
           </a:xfrm>
           <a:prstGeom prst="rect">
@@ -17398,7 +17174,7 @@
         </p:nvSpPr>
         <p:spPr>
           <a:xfrm>
-            <a:off x="3383280" y="2423160"/>
+            <a:off x="3383280" y="2697480"/>
             <a:ext cx="2560320" cy="1188720"/>
           </a:xfrm>
           <a:prstGeom prst="rect">
@@ -17441,7 +17217,7 @@
         </p:nvSpPr>
         <p:spPr>
           <a:xfrm>
-            <a:off x="6217920" y="1920240"/>
+            <a:off x="6217920" y="2194560"/>
             <a:ext cx="2743200" cy="1920240"/>
           </a:xfrm>
           <a:prstGeom prst="roundRect">
@@ -17486,7 +17262,7 @@
         </p:nvSpPr>
         <p:spPr>
           <a:xfrm>
-            <a:off x="6217920" y="1920240"/>
+            <a:off x="6217920" y="2194560"/>
             <a:ext cx="2743200" cy="36576"/>
           </a:xfrm>
           <a:prstGeom prst="rect">
@@ -17529,7 +17305,7 @@
         </p:nvSpPr>
         <p:spPr>
           <a:xfrm>
-            <a:off x="6309360" y="2057400"/>
+            <a:off x="6309360" y="2331720"/>
             <a:ext cx="2560320" cy="320040"/>
           </a:xfrm>
           <a:prstGeom prst="rect">
@@ -17564,7 +17340,7 @@
         </p:nvSpPr>
         <p:spPr>
           <a:xfrm>
-            <a:off x="6309360" y="2423160"/>
+            <a:off x="6309360" y="2697480"/>
             <a:ext cx="2560320" cy="1188720"/>
           </a:xfrm>
           <a:prstGeom prst="rect">
@@ -17607,7 +17383,7 @@
         </p:nvSpPr>
         <p:spPr>
           <a:xfrm>
-            <a:off x="9144000" y="1920240"/>
+            <a:off x="9144000" y="2194560"/>
             <a:ext cx="2743200" cy="1920240"/>
           </a:xfrm>
           <a:prstGeom prst="roundRect">
@@ -17652,7 +17428,7 @@
         </p:nvSpPr>
         <p:spPr>
           <a:xfrm>
-            <a:off x="9144000" y="1920240"/>
+            <a:off x="9144000" y="2194560"/>
             <a:ext cx="2743200" cy="36576"/>
           </a:xfrm>
           <a:prstGeom prst="rect">
@@ -17695,7 +17471,7 @@
         </p:nvSpPr>
         <p:spPr>
           <a:xfrm>
-            <a:off x="9235440" y="2057400"/>
+            <a:off x="9235440" y="2331720"/>
             <a:ext cx="2560320" cy="320040"/>
           </a:xfrm>
           <a:prstGeom prst="rect">
@@ -17730,7 +17506,7 @@
         </p:nvSpPr>
         <p:spPr>
           <a:xfrm>
-            <a:off x="9235440" y="2423160"/>
+            <a:off x="9235440" y="2697480"/>
             <a:ext cx="2560320" cy="1188720"/>
           </a:xfrm>
           <a:prstGeom prst="rect">
@@ -17773,7 +17549,7 @@
         </p:nvSpPr>
         <p:spPr>
           <a:xfrm>
-            <a:off x="365760" y="4114800"/>
+            <a:off x="365760" y="4389120"/>
             <a:ext cx="2743200" cy="1920240"/>
           </a:xfrm>
           <a:prstGeom prst="roundRect">
@@ -17818,7 +17594,7 @@
         </p:nvSpPr>
         <p:spPr>
           <a:xfrm>
-            <a:off x="365760" y="4114800"/>
+            <a:off x="365760" y="4389120"/>
             <a:ext cx="2743200" cy="36576"/>
           </a:xfrm>
           <a:prstGeom prst="rect">
@@ -17861,7 +17637,7 @@
         </p:nvSpPr>
         <p:spPr>
           <a:xfrm>
-            <a:off x="457200" y="4251960"/>
+            <a:off x="457200" y="4526280"/>
             <a:ext cx="2560320" cy="320040"/>
           </a:xfrm>
           <a:prstGeom prst="rect">
@@ -17896,7 +17672,7 @@
         </p:nvSpPr>
         <p:spPr>
           <a:xfrm>
-            <a:off x="457200" y="4617720"/>
+            <a:off x="457200" y="4892040"/>
             <a:ext cx="2560320" cy="1188720"/>
           </a:xfrm>
           <a:prstGeom prst="rect">
@@ -17939,7 +17715,7 @@
         </p:nvSpPr>
         <p:spPr>
           <a:xfrm>
-            <a:off x="3291840" y="4114800"/>
+            <a:off x="3291840" y="4389120"/>
             <a:ext cx="2743200" cy="1920240"/>
           </a:xfrm>
           <a:prstGeom prst="roundRect">
@@ -17984,7 +17760,7 @@
         </p:nvSpPr>
         <p:spPr>
           <a:xfrm>
-            <a:off x="3291840" y="4114800"/>
+            <a:off x="3291840" y="4389120"/>
             <a:ext cx="2743200" cy="36576"/>
           </a:xfrm>
           <a:prstGeom prst="rect">
@@ -18027,7 +17803,7 @@
         </p:nvSpPr>
         <p:spPr>
           <a:xfrm>
-            <a:off x="3383280" y="4251960"/>
+            <a:off x="3383280" y="4526280"/>
             <a:ext cx="2560320" cy="320040"/>
           </a:xfrm>
           <a:prstGeom prst="rect">
@@ -18062,7 +17838,7 @@
         </p:nvSpPr>
         <p:spPr>
           <a:xfrm>
-            <a:off x="3383280" y="4617720"/>
+            <a:off x="3383280" y="4892040"/>
             <a:ext cx="2560320" cy="1188720"/>
           </a:xfrm>
           <a:prstGeom prst="rect">
@@ -18105,7 +17881,7 @@
         </p:nvSpPr>
         <p:spPr>
           <a:xfrm>
-            <a:off x="6217920" y="4114800"/>
+            <a:off x="6217920" y="4389120"/>
             <a:ext cx="2743200" cy="1920240"/>
           </a:xfrm>
           <a:prstGeom prst="roundRect">
@@ -18150,7 +17926,7 @@
         </p:nvSpPr>
         <p:spPr>
           <a:xfrm>
-            <a:off x="6217920" y="4114800"/>
+            <a:off x="6217920" y="4389120"/>
             <a:ext cx="2743200" cy="36576"/>
           </a:xfrm>
           <a:prstGeom prst="rect">
@@ -18193,7 +17969,7 @@
         </p:nvSpPr>
         <p:spPr>
           <a:xfrm>
-            <a:off x="6309360" y="4251960"/>
+            <a:off x="6309360" y="4526280"/>
             <a:ext cx="2560320" cy="320040"/>
           </a:xfrm>
           <a:prstGeom prst="rect">
@@ -18228,7 +18004,7 @@
         </p:nvSpPr>
         <p:spPr>
           <a:xfrm>
-            <a:off x="6309360" y="4617720"/>
+            <a:off x="6309360" y="4892040"/>
             <a:ext cx="2560320" cy="1188720"/>
           </a:xfrm>
           <a:prstGeom prst="rect">
@@ -18271,7 +18047,7 @@
         </p:nvSpPr>
         <p:spPr>
           <a:xfrm>
-            <a:off x="9144000" y="4114800"/>
+            <a:off x="9144000" y="4389120"/>
             <a:ext cx="2743200" cy="1920240"/>
           </a:xfrm>
           <a:prstGeom prst="roundRect">
@@ -18316,7 +18092,7 @@
         </p:nvSpPr>
         <p:spPr>
           <a:xfrm>
-            <a:off x="9144000" y="4114800"/>
+            <a:off x="9144000" y="4389120"/>
             <a:ext cx="2743200" cy="36576"/>
           </a:xfrm>
           <a:prstGeom prst="rect">
@@ -18359,7 +18135,7 @@
         </p:nvSpPr>
         <p:spPr>
           <a:xfrm>
-            <a:off x="9235440" y="4251960"/>
+            <a:off x="9235440" y="4526280"/>
             <a:ext cx="2560320" cy="320040"/>
           </a:xfrm>
           <a:prstGeom prst="rect">
@@ -18394,7 +18170,7 @@
         </p:nvSpPr>
         <p:spPr>
           <a:xfrm>
-            <a:off x="9235440" y="4617720"/>
+            <a:off x="9235440" y="4892040"/>
             <a:ext cx="2560320" cy="1188720"/>
           </a:xfrm>
           <a:prstGeom prst="rect">
@@ -18549,22 +18325,22 @@
         </p:nvSpPr>
         <p:spPr>
           <a:xfrm>
-            <a:off x="914400" y="1097280"/>
-            <a:ext cx="10058400" cy="731520"/>
-          </a:xfrm>
-          <a:prstGeom prst="rect">
-            <a:avLst/>
-          </a:prstGeom>
-          <a:noFill/>
-        </p:spPr>
-        <p:txBody>
-          <a:bodyPr wrap="square">
-            <a:spAutoFit/>
-          </a:bodyPr>
-          <a:lstStyle/>
-          <a:p>
-            <a:pPr algn="l">
-              <a:defRPr sz="3600" b="1">
+            <a:off x="914400" y="914400"/>
+            <a:ext cx="10058400" cy="594360"/>
+          </a:xfrm>
+          <a:prstGeom prst="rect">
+            <a:avLst/>
+          </a:prstGeom>
+          <a:noFill/>
+        </p:spPr>
+        <p:txBody>
+          <a:bodyPr wrap="square">
+            <a:spAutoFit/>
+          </a:bodyPr>
+          <a:lstStyle/>
+          <a:p>
+            <a:pPr algn="l">
+              <a:defRPr sz="3200" b="1">
                 <a:solidFill>
                   <a:srgbClr val="FFFFFF"/>
                 </a:solidFill>
@@ -18584,22 +18360,22 @@
         </p:nvSpPr>
         <p:spPr>
           <a:xfrm>
-            <a:off x="914400" y="1828800"/>
-            <a:ext cx="10058400" cy="457200"/>
-          </a:xfrm>
-          <a:prstGeom prst="rect">
-            <a:avLst/>
-          </a:prstGeom>
-          <a:noFill/>
-        </p:spPr>
-        <p:txBody>
-          <a:bodyPr wrap="square">
-            <a:spAutoFit/>
-          </a:bodyPr>
-          <a:lstStyle/>
-          <a:p>
-            <a:pPr algn="l">
-              <a:defRPr sz="1800" b="0">
+            <a:off x="914400" y="1600200"/>
+            <a:ext cx="10058400" cy="274320"/>
+          </a:xfrm>
+          <a:prstGeom prst="rect">
+            <a:avLst/>
+          </a:prstGeom>
+          <a:noFill/>
+        </p:spPr>
+        <p:txBody>
+          <a:bodyPr wrap="square">
+            <a:spAutoFit/>
+          </a:bodyPr>
+          <a:lstStyle/>
+          <a:p>
+            <a:pPr algn="l">
+              <a:defRPr sz="1400" b="0">
                 <a:solidFill>
                   <a:srgbClr val="9CA3AF"/>
                 </a:solidFill>
@@ -18619,7 +18395,7 @@
         </p:nvSpPr>
         <p:spPr>
           <a:xfrm>
-            <a:off x="548640" y="2011680"/>
+            <a:off x="548640" y="2286000"/>
             <a:ext cx="5394960" cy="1920240"/>
           </a:xfrm>
           <a:prstGeom prst="roundRect">
@@ -18664,7 +18440,7 @@
         </p:nvSpPr>
         <p:spPr>
           <a:xfrm>
-            <a:off x="731520" y="2103120"/>
+            <a:off x="731520" y="2377440"/>
             <a:ext cx="5029200" cy="365760"/>
           </a:xfrm>
           <a:prstGeom prst="rect">
@@ -18699,7 +18475,7 @@
         </p:nvSpPr>
         <p:spPr>
           <a:xfrm>
-            <a:off x="731520" y="2514600"/>
+            <a:off x="731520" y="2788920"/>
             <a:ext cx="5029200" cy="1280160"/>
           </a:xfrm>
           <a:prstGeom prst="rect">
@@ -18742,7 +18518,7 @@
         </p:nvSpPr>
         <p:spPr>
           <a:xfrm>
-            <a:off x="6309360" y="2011680"/>
+            <a:off x="6309360" y="2286000"/>
             <a:ext cx="5394960" cy="1920240"/>
           </a:xfrm>
           <a:prstGeom prst="roundRect">
@@ -18787,7 +18563,7 @@
         </p:nvSpPr>
         <p:spPr>
           <a:xfrm>
-            <a:off x="6492240" y="2103120"/>
+            <a:off x="6492240" y="2377440"/>
             <a:ext cx="5029200" cy="365760"/>
           </a:xfrm>
           <a:prstGeom prst="rect">
@@ -18822,7 +18598,7 @@
         </p:nvSpPr>
         <p:spPr>
           <a:xfrm>
-            <a:off x="6492240" y="2514600"/>
+            <a:off x="6492240" y="2788920"/>
             <a:ext cx="5029200" cy="1280160"/>
           </a:xfrm>
           <a:prstGeom prst="rect">
@@ -18865,7 +18641,7 @@
         </p:nvSpPr>
         <p:spPr>
           <a:xfrm>
-            <a:off x="548640" y="4206240"/>
+            <a:off x="548640" y="4480560"/>
             <a:ext cx="5394960" cy="1920240"/>
           </a:xfrm>
           <a:prstGeom prst="roundRect">
@@ -18910,7 +18686,7 @@
         </p:nvSpPr>
         <p:spPr>
           <a:xfrm>
-            <a:off x="731520" y="4297680"/>
+            <a:off x="731520" y="4572000"/>
             <a:ext cx="5029200" cy="365760"/>
           </a:xfrm>
           <a:prstGeom prst="rect">
@@ -18945,7 +18721,7 @@
         </p:nvSpPr>
         <p:spPr>
           <a:xfrm>
-            <a:off x="731520" y="4709160"/>
+            <a:off x="731520" y="4983480"/>
             <a:ext cx="5029200" cy="1280160"/>
           </a:xfrm>
           <a:prstGeom prst="rect">
@@ -18988,7 +18764,7 @@
         </p:nvSpPr>
         <p:spPr>
           <a:xfrm>
-            <a:off x="6309360" y="4206240"/>
+            <a:off x="6309360" y="4480560"/>
             <a:ext cx="5394960" cy="1920240"/>
           </a:xfrm>
           <a:prstGeom prst="roundRect">
@@ -19033,7 +18809,7 @@
         </p:nvSpPr>
         <p:spPr>
           <a:xfrm>
-            <a:off x="6492240" y="4297680"/>
+            <a:off x="6492240" y="4572000"/>
             <a:ext cx="5029200" cy="365760"/>
           </a:xfrm>
           <a:prstGeom prst="rect">
@@ -19068,7 +18844,7 @@
         </p:nvSpPr>
         <p:spPr>
           <a:xfrm>
-            <a:off x="6492240" y="4709160"/>
+            <a:off x="6492240" y="4983480"/>
             <a:ext cx="5029200" cy="1280160"/>
           </a:xfrm>
           <a:prstGeom prst="rect">
@@ -19223,22 +18999,22 @@
         </p:nvSpPr>
         <p:spPr>
           <a:xfrm>
-            <a:off x="914400" y="1097280"/>
-            <a:ext cx="10058400" cy="731520"/>
-          </a:xfrm>
-          <a:prstGeom prst="rect">
-            <a:avLst/>
-          </a:prstGeom>
-          <a:noFill/>
-        </p:spPr>
-        <p:txBody>
-          <a:bodyPr wrap="square">
-            <a:spAutoFit/>
-          </a:bodyPr>
-          <a:lstStyle/>
-          <a:p>
-            <a:pPr algn="l">
-              <a:defRPr sz="3600" b="1">
+            <a:off x="914400" y="914400"/>
+            <a:ext cx="10058400" cy="594360"/>
+          </a:xfrm>
+          <a:prstGeom prst="rect">
+            <a:avLst/>
+          </a:prstGeom>
+          <a:noFill/>
+        </p:spPr>
+        <p:txBody>
+          <a:bodyPr wrap="square">
+            <a:spAutoFit/>
+          </a:bodyPr>
+          <a:lstStyle/>
+          <a:p>
+            <a:pPr algn="l">
+              <a:defRPr sz="3200" b="1">
                 <a:solidFill>
                   <a:srgbClr val="FFFFFF"/>
                 </a:solidFill>
@@ -19258,22 +19034,22 @@
         </p:nvSpPr>
         <p:spPr>
           <a:xfrm>
-            <a:off x="914400" y="1828800"/>
-            <a:ext cx="10058400" cy="457200"/>
-          </a:xfrm>
-          <a:prstGeom prst="rect">
-            <a:avLst/>
-          </a:prstGeom>
-          <a:noFill/>
-        </p:spPr>
-        <p:txBody>
-          <a:bodyPr wrap="square">
-            <a:spAutoFit/>
-          </a:bodyPr>
-          <a:lstStyle/>
-          <a:p>
-            <a:pPr algn="l">
-              <a:defRPr sz="1800" b="0">
+            <a:off x="914400" y="1600200"/>
+            <a:ext cx="10058400" cy="274320"/>
+          </a:xfrm>
+          <a:prstGeom prst="rect">
+            <a:avLst/>
+          </a:prstGeom>
+          <a:noFill/>
+        </p:spPr>
+        <p:txBody>
+          <a:bodyPr wrap="square">
+            <a:spAutoFit/>
+          </a:bodyPr>
+          <a:lstStyle/>
+          <a:p>
+            <a:pPr algn="l">
+              <a:defRPr sz="1400" b="0">
                 <a:solidFill>
                   <a:srgbClr val="9CA3AF"/>
                 </a:solidFill>
@@ -19885,22 +19661,22 @@
         </p:nvSpPr>
         <p:spPr>
           <a:xfrm>
-            <a:off x="914400" y="1097280"/>
-            <a:ext cx="10058400" cy="731520"/>
-          </a:xfrm>
-          <a:prstGeom prst="rect">
-            <a:avLst/>
-          </a:prstGeom>
-          <a:noFill/>
-        </p:spPr>
-        <p:txBody>
-          <a:bodyPr wrap="square">
-            <a:spAutoFit/>
-          </a:bodyPr>
-          <a:lstStyle/>
-          <a:p>
-            <a:pPr algn="l">
-              <a:defRPr sz="3600" b="1">
+            <a:off x="914400" y="914400"/>
+            <a:ext cx="10058400" cy="594360"/>
+          </a:xfrm>
+          <a:prstGeom prst="rect">
+            <a:avLst/>
+          </a:prstGeom>
+          <a:noFill/>
+        </p:spPr>
+        <p:txBody>
+          <a:bodyPr wrap="square">
+            <a:spAutoFit/>
+          </a:bodyPr>
+          <a:lstStyle/>
+          <a:p>
+            <a:pPr algn="l">
+              <a:defRPr sz="3200" b="1">
                 <a:solidFill>
                   <a:srgbClr val="FFFFFF"/>
                 </a:solidFill>
@@ -19920,22 +19696,22 @@
         </p:nvSpPr>
         <p:spPr>
           <a:xfrm>
-            <a:off x="914400" y="1828800"/>
-            <a:ext cx="10058400" cy="457200"/>
-          </a:xfrm>
-          <a:prstGeom prst="rect">
-            <a:avLst/>
-          </a:prstGeom>
-          <a:noFill/>
-        </p:spPr>
-        <p:txBody>
-          <a:bodyPr wrap="square">
-            <a:spAutoFit/>
-          </a:bodyPr>
-          <a:lstStyle/>
-          <a:p>
-            <a:pPr algn="l">
-              <a:defRPr sz="1800" b="0">
+            <a:off x="914400" y="1600200"/>
+            <a:ext cx="10058400" cy="274320"/>
+          </a:xfrm>
+          <a:prstGeom prst="rect">
+            <a:avLst/>
+          </a:prstGeom>
+          <a:noFill/>
+        </p:spPr>
+        <p:txBody>
+          <a:bodyPr wrap="square">
+            <a:spAutoFit/>
+          </a:bodyPr>
+          <a:lstStyle/>
+          <a:p>
+            <a:pPr algn="l">
+              <a:defRPr sz="1400" b="0">
                 <a:solidFill>
                   <a:srgbClr val="9CA3AF"/>
                 </a:solidFill>
@@ -19955,7 +19731,7 @@
         </p:nvSpPr>
         <p:spPr>
           <a:xfrm>
-            <a:off x="548640" y="2011680"/>
+            <a:off x="548640" y="2286000"/>
             <a:ext cx="5394960" cy="1920240"/>
           </a:xfrm>
           <a:prstGeom prst="roundRect">
@@ -20000,7 +19776,7 @@
         </p:nvSpPr>
         <p:spPr>
           <a:xfrm>
-            <a:off x="731520" y="2103120"/>
+            <a:off x="731520" y="2377440"/>
             <a:ext cx="5029200" cy="365760"/>
           </a:xfrm>
           <a:prstGeom prst="rect">
@@ -20035,7 +19811,7 @@
         </p:nvSpPr>
         <p:spPr>
           <a:xfrm>
-            <a:off x="731520" y="2514600"/>
+            <a:off x="731520" y="2788920"/>
             <a:ext cx="5029200" cy="1280160"/>
           </a:xfrm>
           <a:prstGeom prst="rect">
@@ -20086,7 +19862,7 @@
         </p:nvSpPr>
         <p:spPr>
           <a:xfrm>
-            <a:off x="6309360" y="2011680"/>
+            <a:off x="6309360" y="2286000"/>
             <a:ext cx="5394960" cy="1920240"/>
           </a:xfrm>
           <a:prstGeom prst="roundRect">
@@ -20131,7 +19907,7 @@
         </p:nvSpPr>
         <p:spPr>
           <a:xfrm>
-            <a:off x="6492240" y="2103120"/>
+            <a:off x="6492240" y="2377440"/>
             <a:ext cx="5029200" cy="365760"/>
           </a:xfrm>
           <a:prstGeom prst="rect">
@@ -20166,7 +19942,7 @@
         </p:nvSpPr>
         <p:spPr>
           <a:xfrm>
-            <a:off x="6492240" y="2514600"/>
+            <a:off x="6492240" y="2788920"/>
             <a:ext cx="5029200" cy="1280160"/>
           </a:xfrm>
           <a:prstGeom prst="rect">
@@ -20213,7 +19989,7 @@
         </p:nvSpPr>
         <p:spPr>
           <a:xfrm>
-            <a:off x="548640" y="4206240"/>
+            <a:off x="548640" y="4480560"/>
             <a:ext cx="5394960" cy="1920240"/>
           </a:xfrm>
           <a:prstGeom prst="roundRect">
@@ -20258,7 +20034,7 @@
         </p:nvSpPr>
         <p:spPr>
           <a:xfrm>
-            <a:off x="731520" y="4297680"/>
+            <a:off x="731520" y="4572000"/>
             <a:ext cx="5029200" cy="365760"/>
           </a:xfrm>
           <a:prstGeom prst="rect">
@@ -20293,7 +20069,7 @@
         </p:nvSpPr>
         <p:spPr>
           <a:xfrm>
-            <a:off x="731520" y="4709160"/>
+            <a:off x="731520" y="4983480"/>
             <a:ext cx="5029200" cy="1280160"/>
           </a:xfrm>
           <a:prstGeom prst="rect">
@@ -20340,7 +20116,7 @@
         </p:nvSpPr>
         <p:spPr>
           <a:xfrm>
-            <a:off x="6309360" y="4206240"/>
+            <a:off x="6309360" y="4480560"/>
             <a:ext cx="5394960" cy="1920240"/>
           </a:xfrm>
           <a:prstGeom prst="roundRect">
@@ -20385,7 +20161,7 @@
         </p:nvSpPr>
         <p:spPr>
           <a:xfrm>
-            <a:off x="6492240" y="4297680"/>
+            <a:off x="6492240" y="4572000"/>
             <a:ext cx="5029200" cy="365760"/>
           </a:xfrm>
           <a:prstGeom prst="rect">
@@ -20420,7 +20196,7 @@
         </p:nvSpPr>
         <p:spPr>
           <a:xfrm>
-            <a:off x="6492240" y="4709160"/>
+            <a:off x="6492240" y="4983480"/>
             <a:ext cx="5029200" cy="1280160"/>
           </a:xfrm>
           <a:prstGeom prst="rect">

</xml_diff>

<commit_message>
Mark helmet detection as Beta in backend, UI, and PPT
</commit_message>
<xml_diff>
--- a/TRINETRA_AI_Presentation.pptx
+++ b/TRINETRA_AI_Presentation.pptx
@@ -6290,7 +6290,7 @@
               </a:defRPr>
             </a:pPr>
             <a:r>
-              <a:t>Violation Showcase: No Helmet Detection</a:t>
+              <a:t>Violation Showcase: No Helmet Detection [BETA]</a:t>
             </a:r>
           </a:p>
         </p:txBody>
@@ -6596,7 +6596,7 @@
               </a:defRPr>
             </a:pPr>
             <a:r>
-              <a:t>Confidence: 87% | Risk: 30</a:t>
+              <a:t>Confidence: 87% | Risk: 30 | Beta</a:t>
             </a:r>
           </a:p>
         </p:txBody>
@@ -14358,7 +14358,7 @@
               </a:defRPr>
             </a:pPr>
             <a:r>
-              <a:t>7 violation types: Helmet, Triple Riding, Overloading, Seatbelt, Wrong Side, Red Light, Stop Line</a:t>
+              <a:t>7 violation types: Helmet (Beta), Triple Riding, Overloading, Seatbelt, Wrong Side, Red Light, Stop Line</a:t>
             </a:r>
           </a:p>
         </p:txBody>
@@ -16995,7 +16995,7 @@
               </a:defRPr>
             </a:pPr>
             <a:r>
-              <a:t>No Helmet</a:t>
+              <a:t>No Helmet [BETA]</a:t>
             </a:r>
           </a:p>
         </p:txBody>
@@ -17034,11 +17034,11 @@
             </a:r>
             <a:br/>
             <a:r>
-              <a:t>YOLO helmet classifier + color analysis.</a:t>
+              <a:t>YOLO helmet classifier (Beta) + HSV fallback.</a:t>
             </a:r>
             <a:br/>
             <a:r>
-              <a:t>Confidence range: 80-98%</a:t>
+              <a:t>Confidence range: 50-90%</a:t>
             </a:r>
           </a:p>
         </p:txBody>

</xml_diff>

<commit_message>
v3.3e highlight OCR success & pedestrian counting in README and PPT
- README: add Key Achievements section (OCR, pedestrian count, helmet,
  triple riding, end-to-end pipeline); promote OCR and person detection
  to top of Features list with ✅ callout
- PPT Slide 5 (Vehicle Detection): add 'accurate pedestrian counting'
  bullet with exact person count per image
- PPT Slide 8 (License Plate OCR): mark as 'WORKING', add success
  callout box, highlight fragment recombination example (KA01AB1234)
</commit_message>
<xml_diff>
--- a/TRINETRA_AI_Presentation.pptx
+++ b/TRINETRA_AI_Presentation.pptx
@@ -16130,7 +16130,7 @@
               </a:defRPr>
             </a:pPr>
             <a:r>
-              <a:t>Detecting and localizing all road users with YOLOv8s (COCO-trained)</a:t>
+              <a:t>Detecting and localizing all road users with YOLOv8s — exact person/pedestrian counts</a:t>
             </a:r>
           </a:p>
         </p:txBody>
@@ -16143,8 +16143,8 @@
         </p:nvSpPr>
         <p:spPr>
           <a:xfrm>
-            <a:off x="731520" y="2377440"/>
-            <a:ext cx="10515600" cy="502920"/>
+            <a:off x="731520" y="2194560"/>
+            <a:ext cx="10515600" cy="457200"/>
           </a:xfrm>
           <a:prstGeom prst="roundRect">
             <a:avLst/>
@@ -16188,7 +16188,7 @@
         </p:nvSpPr>
         <p:spPr>
           <a:xfrm>
-            <a:off x="914400" y="2423160"/>
+            <a:off x="914400" y="2221992"/>
             <a:ext cx="10241280" cy="365760"/>
           </a:xfrm>
           <a:prstGeom prst="rect">
@@ -16203,7 +16203,7 @@
           <a:lstStyle/>
           <a:p>
             <a:pPr algn="l">
-              <a:defRPr sz="1400" b="0">
+              <a:defRPr sz="1300" b="0">
                 <a:solidFill>
                   <a:srgbClr val="FFFFFF"/>
                 </a:solidFill>
@@ -16223,8 +16223,8 @@
         </p:nvSpPr>
         <p:spPr>
           <a:xfrm>
-            <a:off x="731520" y="2971800"/>
-            <a:ext cx="10515600" cy="502920"/>
+            <a:off x="731520" y="2743200"/>
+            <a:ext cx="10515600" cy="457200"/>
           </a:xfrm>
           <a:prstGeom prst="roundRect">
             <a:avLst/>
@@ -16268,7 +16268,7 @@
         </p:nvSpPr>
         <p:spPr>
           <a:xfrm>
-            <a:off x="914400" y="3017520"/>
+            <a:off x="914400" y="2770632"/>
             <a:ext cx="10241280" cy="365760"/>
           </a:xfrm>
           <a:prstGeom prst="rect">
@@ -16283,14 +16283,14 @@
           <a:lstStyle/>
           <a:p>
             <a:pPr algn="l">
-              <a:defRPr sz="1400" b="0">
+              <a:defRPr sz="1300" b="0">
                 <a:solidFill>
                   <a:srgbClr val="FFFFFF"/>
                 </a:solidFill>
               </a:defRPr>
             </a:pPr>
             <a:r>
-              <a:t>  ►  Detection confidence scoring with configurable thresholds</a:t>
+              <a:t>  ►  ✅ Accurate pedestrian counting — exact person count per image, supporting crowd analysis</a:t>
             </a:r>
           </a:p>
         </p:txBody>
@@ -16303,8 +16303,8 @@
         </p:nvSpPr>
         <p:spPr>
           <a:xfrm>
-            <a:off x="731520" y="3566160"/>
-            <a:ext cx="10515600" cy="502920"/>
+            <a:off x="731520" y="3291840"/>
+            <a:ext cx="10515600" cy="457200"/>
           </a:xfrm>
           <a:prstGeom prst="roundRect">
             <a:avLst/>
@@ -16348,7 +16348,7 @@
         </p:nvSpPr>
         <p:spPr>
           <a:xfrm>
-            <a:off x="914400" y="3611880"/>
+            <a:off x="914400" y="3319272"/>
             <a:ext cx="10241280" cy="365760"/>
           </a:xfrm>
           <a:prstGeom prst="rect">
@@ -16363,14 +16363,14 @@
           <a:lstStyle/>
           <a:p>
             <a:pPr algn="l">
-              <a:defRPr sz="1400" b="0">
+              <a:defRPr sz="1300" b="0">
                 <a:solidFill>
                   <a:srgbClr val="FFFFFF"/>
                 </a:solidFill>
               </a:defRPr>
             </a:pPr>
             <a:r>
-              <a:t>  ►  Instance tracking: each detection assigned a unique instance ID</a:t>
+              <a:t>  ►  Detection confidence scoring with configurable thresholds</a:t>
             </a:r>
           </a:p>
         </p:txBody>
@@ -16383,8 +16383,8 @@
         </p:nvSpPr>
         <p:spPr>
           <a:xfrm>
-            <a:off x="731520" y="4160520"/>
-            <a:ext cx="10515600" cy="502920"/>
+            <a:off x="731520" y="3840480"/>
+            <a:ext cx="10515600" cy="457200"/>
           </a:xfrm>
           <a:prstGeom prst="roundRect">
             <a:avLst/>
@@ -16428,7 +16428,7 @@
         </p:nvSpPr>
         <p:spPr>
           <a:xfrm>
-            <a:off x="914400" y="4206240"/>
+            <a:off x="914400" y="3867912"/>
             <a:ext cx="10241280" cy="365760"/>
           </a:xfrm>
           <a:prstGeom prst="rect">
@@ -16443,14 +16443,14 @@
           <a:lstStyle/>
           <a:p>
             <a:pPr algn="l">
-              <a:defRPr sz="1400" b="0">
+              <a:defRPr sz="1300" b="0">
                 <a:solidFill>
                   <a:srgbClr val="FFFFFF"/>
                 </a:solidFill>
               </a:defRPr>
             </a:pPr>
             <a:r>
-              <a:t>  ►  Distance-based rider association for motorcycles</a:t>
+              <a:t>  ►  Instance tracking: each detection assigned a unique instance ID</a:t>
             </a:r>
           </a:p>
         </p:txBody>
@@ -16463,8 +16463,8 @@
         </p:nvSpPr>
         <p:spPr>
           <a:xfrm>
-            <a:off x="731520" y="4754880"/>
-            <a:ext cx="10515600" cy="502920"/>
+            <a:off x="731520" y="4389120"/>
+            <a:ext cx="10515600" cy="457200"/>
           </a:xfrm>
           <a:prstGeom prst="roundRect">
             <a:avLst/>
@@ -16508,7 +16508,7 @@
         </p:nvSpPr>
         <p:spPr>
           <a:xfrm>
-            <a:off x="914400" y="4800600"/>
+            <a:off x="914400" y="4416552"/>
             <a:ext cx="10241280" cy="365760"/>
           </a:xfrm>
           <a:prstGeom prst="rect">
@@ -16523,14 +16523,14 @@
           <a:lstStyle/>
           <a:p>
             <a:pPr algn="l">
-              <a:defRPr sz="1400" b="0">
+              <a:defRPr sz="1300" b="0">
                 <a:solidFill>
                   <a:srgbClr val="FFFFFF"/>
                 </a:solidFill>
               </a:defRPr>
             </a:pPr>
             <a:r>
-              <a:t>  ►  Pedestrian detection and background filtering</a:t>
+              <a:t>  ►  Distance-based rider association for motorcycles</a:t>
             </a:r>
           </a:p>
         </p:txBody>
@@ -16543,8 +16543,8 @@
         </p:nvSpPr>
         <p:spPr>
           <a:xfrm>
-            <a:off x="731520" y="5349240"/>
-            <a:ext cx="10515600" cy="502920"/>
+            <a:off x="731520" y="4937760"/>
+            <a:ext cx="10515600" cy="457200"/>
           </a:xfrm>
           <a:prstGeom prst="roundRect">
             <a:avLst/>
@@ -16588,7 +16588,7 @@
         </p:nvSpPr>
         <p:spPr>
           <a:xfrm>
-            <a:off x="914400" y="5394960"/>
+            <a:off x="914400" y="4965192"/>
             <a:ext cx="10241280" cy="365760"/>
           </a:xfrm>
           <a:prstGeom prst="rect">
@@ -16603,14 +16603,14 @@
           <a:lstStyle/>
           <a:p>
             <a:pPr algn="l">
-              <a:defRPr sz="1400" b="0">
+              <a:defRPr sz="1300" b="0">
                 <a:solidFill>
                   <a:srgbClr val="FFFFFF"/>
                 </a:solidFill>
               </a:defRPr>
             </a:pPr>
             <a:r>
-              <a:t>  ►  4-tier detection engine architecture (YOLO built-in + 3 zero-shot options)</a:t>
+              <a:t>  ►  Pedestrian detection and background filtering</a:t>
             </a:r>
           </a:p>
         </p:txBody>
@@ -16623,8 +16623,8 @@
         </p:nvSpPr>
         <p:spPr>
           <a:xfrm>
-            <a:off x="731520" y="5943600"/>
-            <a:ext cx="10515600" cy="502920"/>
+            <a:off x="731520" y="5486400"/>
+            <a:ext cx="10515600" cy="457200"/>
           </a:xfrm>
           <a:prstGeom prst="roundRect">
             <a:avLst/>
@@ -16668,7 +16668,7 @@
         </p:nvSpPr>
         <p:spPr>
           <a:xfrm>
-            <a:off x="914400" y="5989320"/>
+            <a:off x="914400" y="5513832"/>
             <a:ext cx="10241280" cy="365760"/>
           </a:xfrm>
           <a:prstGeom prst="rect">
@@ -16683,7 +16683,87 @@
           <a:lstStyle/>
           <a:p>
             <a:pPr algn="l">
-              <a:defRPr sz="1400" b="0">
+              <a:defRPr sz="1300" b="0">
+                <a:solidFill>
+                  <a:srgbClr val="FFFFFF"/>
+                </a:solidFill>
+              </a:defRPr>
+            </a:pPr>
+            <a:r>
+              <a:t>  ►  4-tier detection engine architecture (YOLO built-in + 3 zero-shot options)</a:t>
+            </a:r>
+          </a:p>
+        </p:txBody>
+      </p:sp>
+      <p:sp>
+        <p:nvSpPr>
+          <p:cNvPr id="20" name="Rounded Rectangle 19"/>
+          <p:cNvSpPr/>
+          <p:nvPr/>
+        </p:nvSpPr>
+        <p:spPr>
+          <a:xfrm>
+            <a:off x="731520" y="6035040"/>
+            <a:ext cx="10515600" cy="457200"/>
+          </a:xfrm>
+          <a:prstGeom prst="roundRect">
+            <a:avLst/>
+          </a:prstGeom>
+          <a:solidFill>
+            <a:srgbClr val="0D1225"/>
+          </a:solidFill>
+          <a:ln w="12700">
+            <a:solidFill>
+              <a:srgbClr val="C0392B"/>
+            </a:solidFill>
+          </a:ln>
+        </p:spPr>
+        <p:style>
+          <a:lnRef idx="1">
+            <a:schemeClr val="accent1"/>
+          </a:lnRef>
+          <a:fillRef idx="3">
+            <a:schemeClr val="accent1"/>
+          </a:fillRef>
+          <a:effectRef idx="2">
+            <a:schemeClr val="accent1"/>
+          </a:effectRef>
+          <a:fontRef idx="minor">
+            <a:schemeClr val="lt1"/>
+          </a:fontRef>
+        </p:style>
+        <p:txBody>
+          <a:bodyPr rtlCol="0" anchor="ctr"/>
+          <a:lstStyle/>
+          <a:p>
+            <a:pPr algn="ctr"/>
+          </a:p>
+        </p:txBody>
+      </p:sp>
+      <p:sp>
+        <p:nvSpPr>
+          <p:cNvPr id="21" name="TextBox 20"/>
+          <p:cNvSpPr txBox="1"/>
+          <p:nvPr/>
+        </p:nvSpPr>
+        <p:spPr>
+          <a:xfrm>
+            <a:off x="914400" y="6062472"/>
+            <a:ext cx="10241280" cy="365760"/>
+          </a:xfrm>
+          <a:prstGeom prst="rect">
+            <a:avLst/>
+          </a:prstGeom>
+          <a:noFill/>
+        </p:spPr>
+        <p:txBody>
+          <a:bodyPr wrap="square">
+            <a:spAutoFit/>
+          </a:bodyPr>
+          <a:lstStyle/>
+          <a:p>
+            <a:pPr algn="l">
+              <a:defRPr sz="1300" b="0">
                 <a:solidFill>
                   <a:srgbClr val="FFFFFF"/>
                 </a:solidFill>
@@ -19056,7 +19136,7 @@
               </a:defRPr>
             </a:pPr>
             <a:r>
-              <a:t>OCR-based number plate detection and registration text extraction</a:t>
+              <a:t>OCR-based number plate detection and registration text extraction — WORKING</a:t>
             </a:r>
           </a:p>
         </p:txBody>
@@ -19136,7 +19216,7 @@
               </a:defRPr>
             </a:pPr>
             <a:r>
-              <a:t>  1.  Plate detection using YOLO-based region proposal</a:t>
+              <a:t>  1.  Plate detection using YOLO-based region proposal on vehicles</a:t>
             </a:r>
           </a:p>
         </p:txBody>
@@ -19216,7 +19296,7 @@
               </a:defRPr>
             </a:pPr>
             <a:r>
-              <a:t>  2.  OCR engine extracts alphanumeric registration text</a:t>
+              <a:t>  2.  OCR engine (EasyOCR) extracts alphanumeric registration text</a:t>
             </a:r>
           </a:p>
         </p:txBody>
@@ -19296,7 +19376,7 @@
               </a:defRPr>
             </a:pPr>
             <a:r>
-              <a:t>  3.  Confidence scoring for extracted plate text</a:t>
+              <a:t>  3.  ✅ Correctly reads full plate text from traffic images (e.g. KA01, AB, 1234 → "KA01AB1234")</a:t>
             </a:r>
           </a:p>
         </p:txBody>
@@ -19376,7 +19456,7 @@
               </a:defRPr>
             </a:pPr>
             <a:r>
-              <a:t>  4.  Plate visibility assessment: High / Medium / Low</a:t>
+              <a:t>  4.  Confidence scoring for extracted plate text with visibility assessment</a:t>
             </a:r>
           </a:p>
         </p:txBody>
@@ -19456,7 +19536,7 @@
               </a:defRPr>
             </a:pPr>
             <a:r>
-              <a:t>  5.  Enhancement pipeline for low-resolution or angled plates</a:t>
+              <a:t>  5.  Enhancement pipeline for low-resolution, angled, or distant plates</a:t>
             </a:r>
           </a:p>
         </p:txBody>
@@ -19537,6 +19617,133 @@
             </a:pPr>
             <a:r>
               <a:t>  6.  Plate text used for vehicle identification &amp; repeat-offender lookup</a:t>
+            </a:r>
+          </a:p>
+        </p:txBody>
+      </p:sp>
+      <p:sp>
+        <p:nvSpPr>
+          <p:cNvPr id="18" name="Rounded Rectangle 17"/>
+          <p:cNvSpPr/>
+          <p:nvPr/>
+        </p:nvSpPr>
+        <p:spPr>
+          <a:xfrm>
+            <a:off x="7772400" y="2286000"/>
+            <a:ext cx="3474720" cy="1097280"/>
+          </a:xfrm>
+          <a:prstGeom prst="roundRect">
+            <a:avLst/>
+          </a:prstGeom>
+          <a:solidFill>
+            <a:srgbClr val="1A2040"/>
+          </a:solidFill>
+          <a:ln w="12700">
+            <a:solidFill>
+              <a:srgbClr val="34D399"/>
+            </a:solidFill>
+          </a:ln>
+        </p:spPr>
+        <p:style>
+          <a:lnRef idx="1">
+            <a:schemeClr val="accent1"/>
+          </a:lnRef>
+          <a:fillRef idx="3">
+            <a:schemeClr val="accent1"/>
+          </a:fillRef>
+          <a:effectRef idx="2">
+            <a:schemeClr val="accent1"/>
+          </a:effectRef>
+          <a:fontRef idx="minor">
+            <a:schemeClr val="lt1"/>
+          </a:fontRef>
+        </p:style>
+        <p:txBody>
+          <a:bodyPr rtlCol="0" anchor="ctr"/>
+          <a:lstStyle/>
+          <a:p>
+            <a:pPr algn="ctr"/>
+          </a:p>
+        </p:txBody>
+      </p:sp>
+      <p:sp>
+        <p:nvSpPr>
+          <p:cNvPr id="19" name="TextBox 18"/>
+          <p:cNvSpPr txBox="1"/>
+          <p:nvPr/>
+        </p:nvSpPr>
+        <p:spPr>
+          <a:xfrm>
+            <a:off x="7863840" y="2377440"/>
+            <a:ext cx="3291840" cy="274320"/>
+          </a:xfrm>
+          <a:prstGeom prst="rect">
+            <a:avLst/>
+          </a:prstGeom>
+          <a:noFill/>
+        </p:spPr>
+        <p:txBody>
+          <a:bodyPr wrap="square">
+            <a:spAutoFit/>
+          </a:bodyPr>
+          <a:lstStyle/>
+          <a:p>
+            <a:pPr algn="l">
+              <a:defRPr sz="1400" b="1">
+                <a:solidFill>
+                  <a:srgbClr val="34D399"/>
+                </a:solidFill>
+              </a:defRPr>
+            </a:pPr>
+            <a:r>
+              <a:t>OCR Success</a:t>
+            </a:r>
+          </a:p>
+        </p:txBody>
+      </p:sp>
+      <p:sp>
+        <p:nvSpPr>
+          <p:cNvPr id="20" name="TextBox 19"/>
+          <p:cNvSpPr txBox="1"/>
+          <p:nvPr/>
+        </p:nvSpPr>
+        <p:spPr>
+          <a:xfrm>
+            <a:off x="7863840" y="2697480"/>
+            <a:ext cx="3291840" cy="548640"/>
+          </a:xfrm>
+          <a:prstGeom prst="rect">
+            <a:avLst/>
+          </a:prstGeom>
+          <a:noFill/>
+        </p:spPr>
+        <p:txBody>
+          <a:bodyPr wrap="square">
+            <a:spAutoFit/>
+          </a:bodyPr>
+          <a:lstStyle/>
+          <a:p>
+            <a:pPr algn="l">
+              <a:defRPr sz="1100" b="0">
+                <a:solidFill>
+                  <a:srgbClr val="FFFFFF"/>
+                </a:solidFill>
+              </a:defRPr>
+            </a:pPr>
+            <a:r>
+              <a:t>License plate text correctly</a:t>
+            </a:r>
+            <a:br/>
+            <a:r>
+              <a:t>identified from traffic camera</a:t>
+            </a:r>
+            <a:br/>
+            <a:r>
+              <a:t>images with fragment</a:t>
+            </a:r>
+            <a:br/>
+            <a:r>
+              <a:t>recombination.</a:t>
             </a:r>
           </a:p>
         </p:txBody>

</xml_diff>